<commit_message>
Removed personal data from template.pptx
</commit_message>
<xml_diff>
--- a/aspose/slides_foss/_internal/pptx/Template.pptx
+++ b/aspose/slides_foss/_internal/pptx/Template.pptx
@@ -109,7 +109,7 @@
 
 <file path=ppt/slideLayouts/slideLayout1.xml><?xml version="1.0" encoding="utf-8"?>
 <p:sldLayout xmlns:a="http://schemas.openxmlformats.org/drawingml/2006/main" xmlns:r="http://schemas.openxmlformats.org/officeDocument/2006/relationships" xmlns:p="http://schemas.openxmlformats.org/presentationml/2006/main" type="title" preserve="1">
-  <p:cSld name="Титульный слайд">
+  <p:cSld name="Title Slide">
     <p:spTree>
       <p:nvGrpSpPr>
         <p:cNvPr id="1" name=""/>
@@ -126,10 +126,10 @@
       </p:grpSpPr>
       <p:sp>
         <p:nvSpPr>
-          <p:cNvPr id="2" name="Заголовок 1">
-            <a:extLst>
-              <a:ext uri="{FF2B5EF4-FFF2-40B4-BE49-F238E27FC236}">
-                <a16:creationId xmlns:a16="http://schemas.microsoft.com/office/drawing/2014/main" id="{EB85B98B-F41B-B9D7-4786-74C6E0B7080D}"/>
+          <p:cNvPr id="2" name="Title 1">
+            <a:extLst>
+              <a:ext uri="{FF2B5EF4-FFF2-40B4-BE49-F238E27FC236}">
+                <a16:creationId xmlns:a16="http://schemas.microsoft.com/office/drawing/2014/main" id="{499E233D-E380-4054-8636-A936181A7291}"/>
               </a:ext>
             </a:extLst>
           </p:cNvPr>
@@ -155,18 +155,19 @@
           </a:lstStyle>
           <a:p>
             <a:r>
-              <a:rPr lang="ru-RU"/>
-              <a:t>Образец заголовка</a:t>
-            </a:r>
-          </a:p>
-        </p:txBody>
-      </p:sp>
-      <p:sp>
-        <p:nvSpPr>
-          <p:cNvPr id="3" name="Подзаголовок 2">
-            <a:extLst>
-              <a:ext uri="{FF2B5EF4-FFF2-40B4-BE49-F238E27FC236}">
-                <a16:creationId xmlns:a16="http://schemas.microsoft.com/office/drawing/2014/main" id="{7A5A433A-6045-6EAB-EED9-FA6397A2BCA1}"/>
+              <a:rPr lang="en-US"/>
+              <a:t>Click to edit Master title style</a:t>
+            </a:r>
+            <a:endParaRPr lang="ru-RU"/>
+          </a:p>
+        </p:txBody>
+      </p:sp>
+      <p:sp>
+        <p:nvSpPr>
+          <p:cNvPr id="3" name="Subtitle 2">
+            <a:extLst>
+              <a:ext uri="{FF2B5EF4-FFF2-40B4-BE49-F238E27FC236}">
+                <a16:creationId xmlns:a16="http://schemas.microsoft.com/office/drawing/2014/main" id="{B9884E15-2E49-EDD7-5462-A2C618CA1128}"/>
               </a:ext>
             </a:extLst>
           </p:cNvPr>
@@ -225,18 +226,19 @@
           </a:lstStyle>
           <a:p>
             <a:r>
-              <a:rPr lang="ru-RU"/>
-              <a:t>Образец подзаголовка</a:t>
-            </a:r>
-          </a:p>
-        </p:txBody>
-      </p:sp>
-      <p:sp>
-        <p:nvSpPr>
-          <p:cNvPr id="4" name="Дата 3">
-            <a:extLst>
-              <a:ext uri="{FF2B5EF4-FFF2-40B4-BE49-F238E27FC236}">
-                <a16:creationId xmlns:a16="http://schemas.microsoft.com/office/drawing/2014/main" id="{2E0A761B-94B7-6D7F-8F7F-8817E9DA9EAE}"/>
+              <a:rPr lang="en-US"/>
+              <a:t>Click to edit Master subtitle style</a:t>
+            </a:r>
+            <a:endParaRPr lang="ru-RU"/>
+          </a:p>
+        </p:txBody>
+      </p:sp>
+      <p:sp>
+        <p:nvSpPr>
+          <p:cNvPr id="4" name="Date Placeholder 3">
+            <a:extLst>
+              <a:ext uri="{FF2B5EF4-FFF2-40B4-BE49-F238E27FC236}">
+                <a16:creationId xmlns:a16="http://schemas.microsoft.com/office/drawing/2014/main" id="{F965116A-D54A-9A7A-FD44-2D051C5D8CBB}"/>
               </a:ext>
             </a:extLst>
           </p:cNvPr>
@@ -252,9 +254,9 @@
           <a:bodyPr/>
           <a:lstStyle/>
           <a:p>
-            <a:fld id="{9757B1A7-0FDC-40C9-B67F-A43EAC5AEB09}" type="datetimeFigureOut">
+            <a:fld id="{961A2009-0CEE-41C1-939A-B9C723B78133}" type="datetimeFigureOut">
               <a:rPr lang="ru-RU" smtClean="0"/>
-              <a:t>04.02.2026</a:t>
+              <a:t>05.03.2026</a:t>
             </a:fld>
             <a:endParaRPr lang="ru-RU"/>
           </a:p>
@@ -262,10 +264,10 @@
       </p:sp>
       <p:sp>
         <p:nvSpPr>
-          <p:cNvPr id="5" name="Нижний колонтитул 4">
-            <a:extLst>
-              <a:ext uri="{FF2B5EF4-FFF2-40B4-BE49-F238E27FC236}">
-                <a16:creationId xmlns:a16="http://schemas.microsoft.com/office/drawing/2014/main" id="{292F70FE-ABF5-211D-542A-D42CF324C7F8}"/>
+          <p:cNvPr id="5" name="Footer Placeholder 4">
+            <a:extLst>
+              <a:ext uri="{FF2B5EF4-FFF2-40B4-BE49-F238E27FC236}">
+                <a16:creationId xmlns:a16="http://schemas.microsoft.com/office/drawing/2014/main" id="{115E23B8-DADF-4479-E1FC-4C7FBEBAC986}"/>
               </a:ext>
             </a:extLst>
           </p:cNvPr>
@@ -287,10 +289,10 @@
       </p:sp>
       <p:sp>
         <p:nvSpPr>
-          <p:cNvPr id="6" name="Номер слайда 5">
-            <a:extLst>
-              <a:ext uri="{FF2B5EF4-FFF2-40B4-BE49-F238E27FC236}">
-                <a16:creationId xmlns:a16="http://schemas.microsoft.com/office/drawing/2014/main" id="{545FB44B-A0DA-41AC-CAA9-ABE673E51112}"/>
+          <p:cNvPr id="6" name="Slide Number Placeholder 5">
+            <a:extLst>
+              <a:ext uri="{FF2B5EF4-FFF2-40B4-BE49-F238E27FC236}">
+                <a16:creationId xmlns:a16="http://schemas.microsoft.com/office/drawing/2014/main" id="{444547A4-A4FF-6E2D-20B5-F1BBBBAFA849}"/>
               </a:ext>
             </a:extLst>
           </p:cNvPr>
@@ -306,7 +308,7 @@
           <a:bodyPr/>
           <a:lstStyle/>
           <a:p>
-            <a:fld id="{42D7F972-A93D-42B4-85D0-25743E08EB40}" type="slidenum">
+            <a:fld id="{20CA96BB-6BF3-4E52-BE21-7A7A15C0727C}" type="slidenum">
               <a:rPr lang="ru-RU" smtClean="0"/>
               <a:t>‹#›</a:t>
             </a:fld>
@@ -317,7 +319,7 @@
     </p:spTree>
     <p:extLst>
       <p:ext uri="{BB962C8B-B14F-4D97-AF65-F5344CB8AC3E}">
-        <p14:creationId xmlns:p14="http://schemas.microsoft.com/office/powerpoint/2010/main" val="2987912810"/>
+        <p14:creationId xmlns:p14="http://schemas.microsoft.com/office/powerpoint/2010/main" val="68103658"/>
       </p:ext>
     </p:extLst>
   </p:cSld>
@@ -329,7 +331,7 @@
 
 <file path=ppt/slideLayouts/slideLayout10.xml><?xml version="1.0" encoding="utf-8"?>
 <p:sldLayout xmlns:a="http://schemas.openxmlformats.org/drawingml/2006/main" xmlns:r="http://schemas.openxmlformats.org/officeDocument/2006/relationships" xmlns:p="http://schemas.openxmlformats.org/presentationml/2006/main" type="vertTx" preserve="1">
-  <p:cSld name="Заголовок и вертикальный текст">
+  <p:cSld name="Title and Vertical Text">
     <p:spTree>
       <p:nvGrpSpPr>
         <p:cNvPr id="1" name=""/>
@@ -346,10 +348,10 @@
       </p:grpSpPr>
       <p:sp>
         <p:nvSpPr>
-          <p:cNvPr id="2" name="Заголовок 1">
-            <a:extLst>
-              <a:ext uri="{FF2B5EF4-FFF2-40B4-BE49-F238E27FC236}">
-                <a16:creationId xmlns:a16="http://schemas.microsoft.com/office/drawing/2014/main" id="{4E2F1044-037E-5534-3607-D190C2609E8C}"/>
+          <p:cNvPr id="2" name="Title 1">
+            <a:extLst>
+              <a:ext uri="{FF2B5EF4-FFF2-40B4-BE49-F238E27FC236}">
+                <a16:creationId xmlns:a16="http://schemas.microsoft.com/office/drawing/2014/main" id="{4865220C-E01C-5FFD-303B-6E3A60C73FCF}"/>
               </a:ext>
             </a:extLst>
           </p:cNvPr>
@@ -366,18 +368,19 @@
           <a:lstStyle/>
           <a:p>
             <a:r>
-              <a:rPr lang="ru-RU"/>
-              <a:t>Образец заголовка</a:t>
-            </a:r>
-          </a:p>
-        </p:txBody>
-      </p:sp>
-      <p:sp>
-        <p:nvSpPr>
-          <p:cNvPr id="3" name="Вертикальный текст 2">
-            <a:extLst>
-              <a:ext uri="{FF2B5EF4-FFF2-40B4-BE49-F238E27FC236}">
-                <a16:creationId xmlns:a16="http://schemas.microsoft.com/office/drawing/2014/main" id="{1B3F0E9E-8FA9-E173-2CD0-BD251B6E039A}"/>
+              <a:rPr lang="en-US"/>
+              <a:t>Click to edit Master title style</a:t>
+            </a:r>
+            <a:endParaRPr lang="ru-RU"/>
+          </a:p>
+        </p:txBody>
+      </p:sp>
+      <p:sp>
+        <p:nvSpPr>
+          <p:cNvPr id="3" name="Vertical Text Placeholder 2">
+            <a:extLst>
+              <a:ext uri="{FF2B5EF4-FFF2-40B4-BE49-F238E27FC236}">
+                <a16:creationId xmlns:a16="http://schemas.microsoft.com/office/drawing/2014/main" id="{8DBA1D6C-9A98-26C9-A22E-E8F6DE897736}"/>
               </a:ext>
             </a:extLst>
           </p:cNvPr>
@@ -395,46 +398,47 @@
           <a:p>
             <a:pPr lvl="0"/>
             <a:r>
-              <a:rPr lang="ru-RU"/>
-              <a:t>Образец текста</a:t>
+              <a:rPr lang="en-US"/>
+              <a:t>Click to edit Master text styles</a:t>
             </a:r>
           </a:p>
           <a:p>
             <a:pPr lvl="1"/>
             <a:r>
-              <a:rPr lang="ru-RU"/>
-              <a:t>Второй уровень</a:t>
+              <a:rPr lang="en-US"/>
+              <a:t>Second level</a:t>
             </a:r>
           </a:p>
           <a:p>
             <a:pPr lvl="2"/>
             <a:r>
-              <a:rPr lang="ru-RU"/>
-              <a:t>Третий уровень</a:t>
+              <a:rPr lang="en-US"/>
+              <a:t>Third level</a:t>
             </a:r>
           </a:p>
           <a:p>
             <a:pPr lvl="3"/>
             <a:r>
-              <a:rPr lang="ru-RU"/>
-              <a:t>Четвертый уровень</a:t>
+              <a:rPr lang="en-US"/>
+              <a:t>Fourth level</a:t>
             </a:r>
           </a:p>
           <a:p>
             <a:pPr lvl="4"/>
             <a:r>
-              <a:rPr lang="ru-RU"/>
-              <a:t>Пятый уровень</a:t>
-            </a:r>
-          </a:p>
-        </p:txBody>
-      </p:sp>
-      <p:sp>
-        <p:nvSpPr>
-          <p:cNvPr id="4" name="Дата 3">
-            <a:extLst>
-              <a:ext uri="{FF2B5EF4-FFF2-40B4-BE49-F238E27FC236}">
-                <a16:creationId xmlns:a16="http://schemas.microsoft.com/office/drawing/2014/main" id="{F5AF9B6E-2DCB-F1A7-5FFD-6F739C459FE1}"/>
+              <a:rPr lang="en-US"/>
+              <a:t>Fifth level</a:t>
+            </a:r>
+            <a:endParaRPr lang="ru-RU"/>
+          </a:p>
+        </p:txBody>
+      </p:sp>
+      <p:sp>
+        <p:nvSpPr>
+          <p:cNvPr id="4" name="Date Placeholder 3">
+            <a:extLst>
+              <a:ext uri="{FF2B5EF4-FFF2-40B4-BE49-F238E27FC236}">
+                <a16:creationId xmlns:a16="http://schemas.microsoft.com/office/drawing/2014/main" id="{63AB272D-71EF-3FE8-1595-FEEA0FCEAE42}"/>
               </a:ext>
             </a:extLst>
           </p:cNvPr>
@@ -450,9 +454,9 @@
           <a:bodyPr/>
           <a:lstStyle/>
           <a:p>
-            <a:fld id="{9757B1A7-0FDC-40C9-B67F-A43EAC5AEB09}" type="datetimeFigureOut">
+            <a:fld id="{961A2009-0CEE-41C1-939A-B9C723B78133}" type="datetimeFigureOut">
               <a:rPr lang="ru-RU" smtClean="0"/>
-              <a:t>04.02.2026</a:t>
+              <a:t>05.03.2026</a:t>
             </a:fld>
             <a:endParaRPr lang="ru-RU"/>
           </a:p>
@@ -460,10 +464,10 @@
       </p:sp>
       <p:sp>
         <p:nvSpPr>
-          <p:cNvPr id="5" name="Нижний колонтитул 4">
-            <a:extLst>
-              <a:ext uri="{FF2B5EF4-FFF2-40B4-BE49-F238E27FC236}">
-                <a16:creationId xmlns:a16="http://schemas.microsoft.com/office/drawing/2014/main" id="{5C7C73B2-75FE-FEA5-DFA5-8324CE4F7893}"/>
+          <p:cNvPr id="5" name="Footer Placeholder 4">
+            <a:extLst>
+              <a:ext uri="{FF2B5EF4-FFF2-40B4-BE49-F238E27FC236}">
+                <a16:creationId xmlns:a16="http://schemas.microsoft.com/office/drawing/2014/main" id="{DED38D48-AE37-04FB-AF67-303A41F2B47F}"/>
               </a:ext>
             </a:extLst>
           </p:cNvPr>
@@ -485,10 +489,10 @@
       </p:sp>
       <p:sp>
         <p:nvSpPr>
-          <p:cNvPr id="6" name="Номер слайда 5">
-            <a:extLst>
-              <a:ext uri="{FF2B5EF4-FFF2-40B4-BE49-F238E27FC236}">
-                <a16:creationId xmlns:a16="http://schemas.microsoft.com/office/drawing/2014/main" id="{EFE8F061-4747-6CCA-88C8-7948DCF9BEC8}"/>
+          <p:cNvPr id="6" name="Slide Number Placeholder 5">
+            <a:extLst>
+              <a:ext uri="{FF2B5EF4-FFF2-40B4-BE49-F238E27FC236}">
+                <a16:creationId xmlns:a16="http://schemas.microsoft.com/office/drawing/2014/main" id="{A3FD6EAA-AA92-28AE-A414-58B63887E3E1}"/>
               </a:ext>
             </a:extLst>
           </p:cNvPr>
@@ -504,7 +508,7 @@
           <a:bodyPr/>
           <a:lstStyle/>
           <a:p>
-            <a:fld id="{42D7F972-A93D-42B4-85D0-25743E08EB40}" type="slidenum">
+            <a:fld id="{20CA96BB-6BF3-4E52-BE21-7A7A15C0727C}" type="slidenum">
               <a:rPr lang="ru-RU" smtClean="0"/>
               <a:t>‹#›</a:t>
             </a:fld>
@@ -515,7 +519,7 @@
     </p:spTree>
     <p:extLst>
       <p:ext uri="{BB962C8B-B14F-4D97-AF65-F5344CB8AC3E}">
-        <p14:creationId xmlns:p14="http://schemas.microsoft.com/office/powerpoint/2010/main" val="593374534"/>
+        <p14:creationId xmlns:p14="http://schemas.microsoft.com/office/powerpoint/2010/main" val="2362319989"/>
       </p:ext>
     </p:extLst>
   </p:cSld>
@@ -527,7 +531,7 @@
 
 <file path=ppt/slideLayouts/slideLayout11.xml><?xml version="1.0" encoding="utf-8"?>
 <p:sldLayout xmlns:a="http://schemas.openxmlformats.org/drawingml/2006/main" xmlns:r="http://schemas.openxmlformats.org/officeDocument/2006/relationships" xmlns:p="http://schemas.openxmlformats.org/presentationml/2006/main" type="vertTitleAndTx" preserve="1">
-  <p:cSld name="Вертикальный заголовок и текст">
+  <p:cSld name="Vertical Title and Text">
     <p:spTree>
       <p:nvGrpSpPr>
         <p:cNvPr id="1" name=""/>
@@ -544,10 +548,10 @@
       </p:grpSpPr>
       <p:sp>
         <p:nvSpPr>
-          <p:cNvPr id="2" name="Вертикальный заголовок 1">
-            <a:extLst>
-              <a:ext uri="{FF2B5EF4-FFF2-40B4-BE49-F238E27FC236}">
-                <a16:creationId xmlns:a16="http://schemas.microsoft.com/office/drawing/2014/main" id="{62B09C10-78DD-DDA6-C1A5-D01C2BF8CCDD}"/>
+          <p:cNvPr id="2" name="Vertical Title 1">
+            <a:extLst>
+              <a:ext uri="{FF2B5EF4-FFF2-40B4-BE49-F238E27FC236}">
+                <a16:creationId xmlns:a16="http://schemas.microsoft.com/office/drawing/2014/main" id="{7004E85E-4B3B-5434-1A61-6A4BF5CE17A3}"/>
               </a:ext>
             </a:extLst>
           </p:cNvPr>
@@ -569,18 +573,19 @@
           <a:lstStyle/>
           <a:p>
             <a:r>
-              <a:rPr lang="ru-RU"/>
-              <a:t>Образец заголовка</a:t>
-            </a:r>
-          </a:p>
-        </p:txBody>
-      </p:sp>
-      <p:sp>
-        <p:nvSpPr>
-          <p:cNvPr id="3" name="Вертикальный текст 2">
-            <a:extLst>
-              <a:ext uri="{FF2B5EF4-FFF2-40B4-BE49-F238E27FC236}">
-                <a16:creationId xmlns:a16="http://schemas.microsoft.com/office/drawing/2014/main" id="{14B2CFBA-A485-B87F-EE82-4CC8C5C57241}"/>
+              <a:rPr lang="en-US"/>
+              <a:t>Click to edit Master title style</a:t>
+            </a:r>
+            <a:endParaRPr lang="ru-RU"/>
+          </a:p>
+        </p:txBody>
+      </p:sp>
+      <p:sp>
+        <p:nvSpPr>
+          <p:cNvPr id="3" name="Vertical Text Placeholder 2">
+            <a:extLst>
+              <a:ext uri="{FF2B5EF4-FFF2-40B4-BE49-F238E27FC236}">
+                <a16:creationId xmlns:a16="http://schemas.microsoft.com/office/drawing/2014/main" id="{7C954124-5D06-AC30-ECE2-4FD1E5163E26}"/>
               </a:ext>
             </a:extLst>
           </p:cNvPr>
@@ -603,46 +608,47 @@
           <a:p>
             <a:pPr lvl="0"/>
             <a:r>
-              <a:rPr lang="ru-RU"/>
-              <a:t>Образец текста</a:t>
+              <a:rPr lang="en-US"/>
+              <a:t>Click to edit Master text styles</a:t>
             </a:r>
           </a:p>
           <a:p>
             <a:pPr lvl="1"/>
             <a:r>
-              <a:rPr lang="ru-RU"/>
-              <a:t>Второй уровень</a:t>
+              <a:rPr lang="en-US"/>
+              <a:t>Second level</a:t>
             </a:r>
           </a:p>
           <a:p>
             <a:pPr lvl="2"/>
             <a:r>
-              <a:rPr lang="ru-RU"/>
-              <a:t>Третий уровень</a:t>
+              <a:rPr lang="en-US"/>
+              <a:t>Third level</a:t>
             </a:r>
           </a:p>
           <a:p>
             <a:pPr lvl="3"/>
             <a:r>
-              <a:rPr lang="ru-RU"/>
-              <a:t>Четвертый уровень</a:t>
+              <a:rPr lang="en-US"/>
+              <a:t>Fourth level</a:t>
             </a:r>
           </a:p>
           <a:p>
             <a:pPr lvl="4"/>
             <a:r>
-              <a:rPr lang="ru-RU"/>
-              <a:t>Пятый уровень</a:t>
-            </a:r>
-          </a:p>
-        </p:txBody>
-      </p:sp>
-      <p:sp>
-        <p:nvSpPr>
-          <p:cNvPr id="4" name="Дата 3">
-            <a:extLst>
-              <a:ext uri="{FF2B5EF4-FFF2-40B4-BE49-F238E27FC236}">
-                <a16:creationId xmlns:a16="http://schemas.microsoft.com/office/drawing/2014/main" id="{C9E9CEA6-2AF3-45AE-6099-0F3F6720B142}"/>
+              <a:rPr lang="en-US"/>
+              <a:t>Fifth level</a:t>
+            </a:r>
+            <a:endParaRPr lang="ru-RU"/>
+          </a:p>
+        </p:txBody>
+      </p:sp>
+      <p:sp>
+        <p:nvSpPr>
+          <p:cNvPr id="4" name="Date Placeholder 3">
+            <a:extLst>
+              <a:ext uri="{FF2B5EF4-FFF2-40B4-BE49-F238E27FC236}">
+                <a16:creationId xmlns:a16="http://schemas.microsoft.com/office/drawing/2014/main" id="{3FB33C8C-740B-5015-AB94-795FB8839BBF}"/>
               </a:ext>
             </a:extLst>
           </p:cNvPr>
@@ -658,9 +664,9 @@
           <a:bodyPr/>
           <a:lstStyle/>
           <a:p>
-            <a:fld id="{9757B1A7-0FDC-40C9-B67F-A43EAC5AEB09}" type="datetimeFigureOut">
+            <a:fld id="{961A2009-0CEE-41C1-939A-B9C723B78133}" type="datetimeFigureOut">
               <a:rPr lang="ru-RU" smtClean="0"/>
-              <a:t>04.02.2026</a:t>
+              <a:t>05.03.2026</a:t>
             </a:fld>
             <a:endParaRPr lang="ru-RU"/>
           </a:p>
@@ -668,10 +674,10 @@
       </p:sp>
       <p:sp>
         <p:nvSpPr>
-          <p:cNvPr id="5" name="Нижний колонтитул 4">
-            <a:extLst>
-              <a:ext uri="{FF2B5EF4-FFF2-40B4-BE49-F238E27FC236}">
-                <a16:creationId xmlns:a16="http://schemas.microsoft.com/office/drawing/2014/main" id="{CFD85C5B-64B4-BD54-F5D8-1BA9BCA144B7}"/>
+          <p:cNvPr id="5" name="Footer Placeholder 4">
+            <a:extLst>
+              <a:ext uri="{FF2B5EF4-FFF2-40B4-BE49-F238E27FC236}">
+                <a16:creationId xmlns:a16="http://schemas.microsoft.com/office/drawing/2014/main" id="{6EEDB20E-47BE-9BBB-636F-243280703C05}"/>
               </a:ext>
             </a:extLst>
           </p:cNvPr>
@@ -693,10 +699,10 @@
       </p:sp>
       <p:sp>
         <p:nvSpPr>
-          <p:cNvPr id="6" name="Номер слайда 5">
-            <a:extLst>
-              <a:ext uri="{FF2B5EF4-FFF2-40B4-BE49-F238E27FC236}">
-                <a16:creationId xmlns:a16="http://schemas.microsoft.com/office/drawing/2014/main" id="{7208D4DA-2999-49FE-BEF5-53CDD23BE999}"/>
+          <p:cNvPr id="6" name="Slide Number Placeholder 5">
+            <a:extLst>
+              <a:ext uri="{FF2B5EF4-FFF2-40B4-BE49-F238E27FC236}">
+                <a16:creationId xmlns:a16="http://schemas.microsoft.com/office/drawing/2014/main" id="{CD3973F5-7346-7C2B-02DA-76785E69E662}"/>
               </a:ext>
             </a:extLst>
           </p:cNvPr>
@@ -712,7 +718,7 @@
           <a:bodyPr/>
           <a:lstStyle/>
           <a:p>
-            <a:fld id="{42D7F972-A93D-42B4-85D0-25743E08EB40}" type="slidenum">
+            <a:fld id="{20CA96BB-6BF3-4E52-BE21-7A7A15C0727C}" type="slidenum">
               <a:rPr lang="ru-RU" smtClean="0"/>
               <a:t>‹#›</a:t>
             </a:fld>
@@ -723,7 +729,7 @@
     </p:spTree>
     <p:extLst>
       <p:ext uri="{BB962C8B-B14F-4D97-AF65-F5344CB8AC3E}">
-        <p14:creationId xmlns:p14="http://schemas.microsoft.com/office/powerpoint/2010/main" val="275757685"/>
+        <p14:creationId xmlns:p14="http://schemas.microsoft.com/office/powerpoint/2010/main" val="3676086520"/>
       </p:ext>
     </p:extLst>
   </p:cSld>
@@ -735,7 +741,7 @@
 
 <file path=ppt/slideLayouts/slideLayout2.xml><?xml version="1.0" encoding="utf-8"?>
 <p:sldLayout xmlns:a="http://schemas.openxmlformats.org/drawingml/2006/main" xmlns:r="http://schemas.openxmlformats.org/officeDocument/2006/relationships" xmlns:p="http://schemas.openxmlformats.org/presentationml/2006/main" type="obj" preserve="1">
-  <p:cSld name="Заголовок и объект">
+  <p:cSld name="Title and Content">
     <p:spTree>
       <p:nvGrpSpPr>
         <p:cNvPr id="1" name=""/>
@@ -752,10 +758,10 @@
       </p:grpSpPr>
       <p:sp>
         <p:nvSpPr>
-          <p:cNvPr id="2" name="Заголовок 1">
-            <a:extLst>
-              <a:ext uri="{FF2B5EF4-FFF2-40B4-BE49-F238E27FC236}">
-                <a16:creationId xmlns:a16="http://schemas.microsoft.com/office/drawing/2014/main" id="{DDB64D88-439D-F253-1F31-83882A5DE028}"/>
+          <p:cNvPr id="2" name="Title 1">
+            <a:extLst>
+              <a:ext uri="{FF2B5EF4-FFF2-40B4-BE49-F238E27FC236}">
+                <a16:creationId xmlns:a16="http://schemas.microsoft.com/office/drawing/2014/main" id="{57D1FF83-FF45-F9CD-DB85-22C2364AC7D3}"/>
               </a:ext>
             </a:extLst>
           </p:cNvPr>
@@ -772,18 +778,19 @@
           <a:lstStyle/>
           <a:p>
             <a:r>
-              <a:rPr lang="ru-RU"/>
-              <a:t>Образец заголовка</a:t>
-            </a:r>
-          </a:p>
-        </p:txBody>
-      </p:sp>
-      <p:sp>
-        <p:nvSpPr>
-          <p:cNvPr id="3" name="Объект 2">
-            <a:extLst>
-              <a:ext uri="{FF2B5EF4-FFF2-40B4-BE49-F238E27FC236}">
-                <a16:creationId xmlns:a16="http://schemas.microsoft.com/office/drawing/2014/main" id="{95B9FF20-AE52-AF8D-B790-CBCE6D02DB45}"/>
+              <a:rPr lang="en-US"/>
+              <a:t>Click to edit Master title style</a:t>
+            </a:r>
+            <a:endParaRPr lang="ru-RU"/>
+          </a:p>
+        </p:txBody>
+      </p:sp>
+      <p:sp>
+        <p:nvSpPr>
+          <p:cNvPr id="3" name="Content Placeholder 2">
+            <a:extLst>
+              <a:ext uri="{FF2B5EF4-FFF2-40B4-BE49-F238E27FC236}">
+                <a16:creationId xmlns:a16="http://schemas.microsoft.com/office/drawing/2014/main" id="{729DC82F-2D07-0CA2-6C73-43883C3FBD4C}"/>
               </a:ext>
             </a:extLst>
           </p:cNvPr>
@@ -801,46 +808,47 @@
           <a:p>
             <a:pPr lvl="0"/>
             <a:r>
-              <a:rPr lang="ru-RU"/>
-              <a:t>Образец текста</a:t>
+              <a:rPr lang="en-US"/>
+              <a:t>Click to edit Master text styles</a:t>
             </a:r>
           </a:p>
           <a:p>
             <a:pPr lvl="1"/>
             <a:r>
-              <a:rPr lang="ru-RU"/>
-              <a:t>Второй уровень</a:t>
+              <a:rPr lang="en-US"/>
+              <a:t>Second level</a:t>
             </a:r>
           </a:p>
           <a:p>
             <a:pPr lvl="2"/>
             <a:r>
-              <a:rPr lang="ru-RU"/>
-              <a:t>Третий уровень</a:t>
+              <a:rPr lang="en-US"/>
+              <a:t>Third level</a:t>
             </a:r>
           </a:p>
           <a:p>
             <a:pPr lvl="3"/>
             <a:r>
-              <a:rPr lang="ru-RU"/>
-              <a:t>Четвертый уровень</a:t>
+              <a:rPr lang="en-US"/>
+              <a:t>Fourth level</a:t>
             </a:r>
           </a:p>
           <a:p>
             <a:pPr lvl="4"/>
             <a:r>
-              <a:rPr lang="ru-RU"/>
-              <a:t>Пятый уровень</a:t>
-            </a:r>
-          </a:p>
-        </p:txBody>
-      </p:sp>
-      <p:sp>
-        <p:nvSpPr>
-          <p:cNvPr id="4" name="Дата 3">
-            <a:extLst>
-              <a:ext uri="{FF2B5EF4-FFF2-40B4-BE49-F238E27FC236}">
-                <a16:creationId xmlns:a16="http://schemas.microsoft.com/office/drawing/2014/main" id="{642D88CD-E554-F971-9486-9167541FC528}"/>
+              <a:rPr lang="en-US"/>
+              <a:t>Fifth level</a:t>
+            </a:r>
+            <a:endParaRPr lang="ru-RU"/>
+          </a:p>
+        </p:txBody>
+      </p:sp>
+      <p:sp>
+        <p:nvSpPr>
+          <p:cNvPr id="4" name="Date Placeholder 3">
+            <a:extLst>
+              <a:ext uri="{FF2B5EF4-FFF2-40B4-BE49-F238E27FC236}">
+                <a16:creationId xmlns:a16="http://schemas.microsoft.com/office/drawing/2014/main" id="{CCE3BE2F-E942-72AE-657D-1EF606F3327B}"/>
               </a:ext>
             </a:extLst>
           </p:cNvPr>
@@ -856,9 +864,9 @@
           <a:bodyPr/>
           <a:lstStyle/>
           <a:p>
-            <a:fld id="{9757B1A7-0FDC-40C9-B67F-A43EAC5AEB09}" type="datetimeFigureOut">
+            <a:fld id="{961A2009-0CEE-41C1-939A-B9C723B78133}" type="datetimeFigureOut">
               <a:rPr lang="ru-RU" smtClean="0"/>
-              <a:t>04.02.2026</a:t>
+              <a:t>05.03.2026</a:t>
             </a:fld>
             <a:endParaRPr lang="ru-RU"/>
           </a:p>
@@ -866,10 +874,10 @@
       </p:sp>
       <p:sp>
         <p:nvSpPr>
-          <p:cNvPr id="5" name="Нижний колонтитул 4">
-            <a:extLst>
-              <a:ext uri="{FF2B5EF4-FFF2-40B4-BE49-F238E27FC236}">
-                <a16:creationId xmlns:a16="http://schemas.microsoft.com/office/drawing/2014/main" id="{E918C2D8-E7E8-EB18-A549-856E91F1B36D}"/>
+          <p:cNvPr id="5" name="Footer Placeholder 4">
+            <a:extLst>
+              <a:ext uri="{FF2B5EF4-FFF2-40B4-BE49-F238E27FC236}">
+                <a16:creationId xmlns:a16="http://schemas.microsoft.com/office/drawing/2014/main" id="{10A5D966-EB44-DAEE-CD5D-276D6A002020}"/>
               </a:ext>
             </a:extLst>
           </p:cNvPr>
@@ -891,10 +899,10 @@
       </p:sp>
       <p:sp>
         <p:nvSpPr>
-          <p:cNvPr id="6" name="Номер слайда 5">
-            <a:extLst>
-              <a:ext uri="{FF2B5EF4-FFF2-40B4-BE49-F238E27FC236}">
-                <a16:creationId xmlns:a16="http://schemas.microsoft.com/office/drawing/2014/main" id="{361C6171-7718-3A49-A60C-D2BB3E9C8234}"/>
+          <p:cNvPr id="6" name="Slide Number Placeholder 5">
+            <a:extLst>
+              <a:ext uri="{FF2B5EF4-FFF2-40B4-BE49-F238E27FC236}">
+                <a16:creationId xmlns:a16="http://schemas.microsoft.com/office/drawing/2014/main" id="{17AAE6AA-4DE5-186F-6FA5-EAA06F218BC0}"/>
               </a:ext>
             </a:extLst>
           </p:cNvPr>
@@ -910,7 +918,7 @@
           <a:bodyPr/>
           <a:lstStyle/>
           <a:p>
-            <a:fld id="{42D7F972-A93D-42B4-85D0-25743E08EB40}" type="slidenum">
+            <a:fld id="{20CA96BB-6BF3-4E52-BE21-7A7A15C0727C}" type="slidenum">
               <a:rPr lang="ru-RU" smtClean="0"/>
               <a:t>‹#›</a:t>
             </a:fld>
@@ -921,7 +929,7 @@
     </p:spTree>
     <p:extLst>
       <p:ext uri="{BB962C8B-B14F-4D97-AF65-F5344CB8AC3E}">
-        <p14:creationId xmlns:p14="http://schemas.microsoft.com/office/powerpoint/2010/main" val="2873335581"/>
+        <p14:creationId xmlns:p14="http://schemas.microsoft.com/office/powerpoint/2010/main" val="2133250215"/>
       </p:ext>
     </p:extLst>
   </p:cSld>
@@ -933,7 +941,7 @@
 
 <file path=ppt/slideLayouts/slideLayout3.xml><?xml version="1.0" encoding="utf-8"?>
 <p:sldLayout xmlns:a="http://schemas.openxmlformats.org/drawingml/2006/main" xmlns:r="http://schemas.openxmlformats.org/officeDocument/2006/relationships" xmlns:p="http://schemas.openxmlformats.org/presentationml/2006/main" type="secHead" preserve="1">
-  <p:cSld name="Заголовок раздела">
+  <p:cSld name="Section Header">
     <p:spTree>
       <p:nvGrpSpPr>
         <p:cNvPr id="1" name=""/>
@@ -950,10 +958,10 @@
       </p:grpSpPr>
       <p:sp>
         <p:nvSpPr>
-          <p:cNvPr id="2" name="Заголовок 1">
-            <a:extLst>
-              <a:ext uri="{FF2B5EF4-FFF2-40B4-BE49-F238E27FC236}">
-                <a16:creationId xmlns:a16="http://schemas.microsoft.com/office/drawing/2014/main" id="{39C450D2-1D78-75B4-D9CB-AB5B97756A60}"/>
+          <p:cNvPr id="2" name="Title 1">
+            <a:extLst>
+              <a:ext uri="{FF2B5EF4-FFF2-40B4-BE49-F238E27FC236}">
+                <a16:creationId xmlns:a16="http://schemas.microsoft.com/office/drawing/2014/main" id="{D16EB0BF-FF83-28D8-D4A5-1B97C098A11F}"/>
               </a:ext>
             </a:extLst>
           </p:cNvPr>
@@ -979,18 +987,19 @@
           </a:lstStyle>
           <a:p>
             <a:r>
-              <a:rPr lang="ru-RU"/>
-              <a:t>Образец заголовка</a:t>
-            </a:r>
-          </a:p>
-        </p:txBody>
-      </p:sp>
-      <p:sp>
-        <p:nvSpPr>
-          <p:cNvPr id="3" name="Текст 2">
-            <a:extLst>
-              <a:ext uri="{FF2B5EF4-FFF2-40B4-BE49-F238E27FC236}">
-                <a16:creationId xmlns:a16="http://schemas.microsoft.com/office/drawing/2014/main" id="{B2218424-0D34-1206-BFE8-57226F987597}"/>
+              <a:rPr lang="en-US"/>
+              <a:t>Click to edit Master title style</a:t>
+            </a:r>
+            <a:endParaRPr lang="ru-RU"/>
+          </a:p>
+        </p:txBody>
+      </p:sp>
+      <p:sp>
+        <p:nvSpPr>
+          <p:cNvPr id="3" name="Text Placeholder 2">
+            <a:extLst>
+              <a:ext uri="{FF2B5EF4-FFF2-40B4-BE49-F238E27FC236}">
+                <a16:creationId xmlns:a16="http://schemas.microsoft.com/office/drawing/2014/main" id="{CF6A6750-0987-5071-00E1-CB2CEA719424}"/>
               </a:ext>
             </a:extLst>
           </p:cNvPr>
@@ -1015,7 +1024,7 @@
               <a:defRPr sz="2400">
                 <a:solidFill>
                   <a:schemeClr val="tx1">
-                    <a:tint val="75000"/>
+                    <a:tint val="82000"/>
                   </a:schemeClr>
                 </a:solidFill>
               </a:defRPr>
@@ -1025,7 +1034,7 @@
               <a:defRPr sz="2000">
                 <a:solidFill>
                   <a:schemeClr val="tx1">
-                    <a:tint val="75000"/>
+                    <a:tint val="82000"/>
                   </a:schemeClr>
                 </a:solidFill>
               </a:defRPr>
@@ -1035,7 +1044,7 @@
               <a:defRPr sz="1800">
                 <a:solidFill>
                   <a:schemeClr val="tx1">
-                    <a:tint val="75000"/>
+                    <a:tint val="82000"/>
                   </a:schemeClr>
                 </a:solidFill>
               </a:defRPr>
@@ -1045,7 +1054,7 @@
               <a:defRPr sz="1600">
                 <a:solidFill>
                   <a:schemeClr val="tx1">
-                    <a:tint val="75000"/>
+                    <a:tint val="82000"/>
                   </a:schemeClr>
                 </a:solidFill>
               </a:defRPr>
@@ -1055,7 +1064,7 @@
               <a:defRPr sz="1600">
                 <a:solidFill>
                   <a:schemeClr val="tx1">
-                    <a:tint val="75000"/>
+                    <a:tint val="82000"/>
                   </a:schemeClr>
                 </a:solidFill>
               </a:defRPr>
@@ -1065,7 +1074,7 @@
               <a:defRPr sz="1600">
                 <a:solidFill>
                   <a:schemeClr val="tx1">
-                    <a:tint val="75000"/>
+                    <a:tint val="82000"/>
                   </a:schemeClr>
                 </a:solidFill>
               </a:defRPr>
@@ -1075,7 +1084,7 @@
               <a:defRPr sz="1600">
                 <a:solidFill>
                   <a:schemeClr val="tx1">
-                    <a:tint val="75000"/>
+                    <a:tint val="82000"/>
                   </a:schemeClr>
                 </a:solidFill>
               </a:defRPr>
@@ -1085,7 +1094,7 @@
               <a:defRPr sz="1600">
                 <a:solidFill>
                   <a:schemeClr val="tx1">
-                    <a:tint val="75000"/>
+                    <a:tint val="82000"/>
                   </a:schemeClr>
                 </a:solidFill>
               </a:defRPr>
@@ -1095,7 +1104,7 @@
               <a:defRPr sz="1600">
                 <a:solidFill>
                   <a:schemeClr val="tx1">
-                    <a:tint val="75000"/>
+                    <a:tint val="82000"/>
                   </a:schemeClr>
                 </a:solidFill>
               </a:defRPr>
@@ -1104,18 +1113,18 @@
           <a:p>
             <a:pPr lvl="0"/>
             <a:r>
-              <a:rPr lang="ru-RU"/>
-              <a:t>Образец текста</a:t>
-            </a:r>
-          </a:p>
-        </p:txBody>
-      </p:sp>
-      <p:sp>
-        <p:nvSpPr>
-          <p:cNvPr id="4" name="Дата 3">
-            <a:extLst>
-              <a:ext uri="{FF2B5EF4-FFF2-40B4-BE49-F238E27FC236}">
-                <a16:creationId xmlns:a16="http://schemas.microsoft.com/office/drawing/2014/main" id="{6FE178D1-9F76-103D-7A8C-41473E927314}"/>
+              <a:rPr lang="en-US"/>
+              <a:t>Click to edit Master text styles</a:t>
+            </a:r>
+          </a:p>
+        </p:txBody>
+      </p:sp>
+      <p:sp>
+        <p:nvSpPr>
+          <p:cNvPr id="4" name="Date Placeholder 3">
+            <a:extLst>
+              <a:ext uri="{FF2B5EF4-FFF2-40B4-BE49-F238E27FC236}">
+                <a16:creationId xmlns:a16="http://schemas.microsoft.com/office/drawing/2014/main" id="{FDDF00D8-A330-B33F-3FE3-4713DBC0256B}"/>
               </a:ext>
             </a:extLst>
           </p:cNvPr>
@@ -1131,9 +1140,9 @@
           <a:bodyPr/>
           <a:lstStyle/>
           <a:p>
-            <a:fld id="{9757B1A7-0FDC-40C9-B67F-A43EAC5AEB09}" type="datetimeFigureOut">
+            <a:fld id="{961A2009-0CEE-41C1-939A-B9C723B78133}" type="datetimeFigureOut">
               <a:rPr lang="ru-RU" smtClean="0"/>
-              <a:t>04.02.2026</a:t>
+              <a:t>05.03.2026</a:t>
             </a:fld>
             <a:endParaRPr lang="ru-RU"/>
           </a:p>
@@ -1141,10 +1150,10 @@
       </p:sp>
       <p:sp>
         <p:nvSpPr>
-          <p:cNvPr id="5" name="Нижний колонтитул 4">
-            <a:extLst>
-              <a:ext uri="{FF2B5EF4-FFF2-40B4-BE49-F238E27FC236}">
-                <a16:creationId xmlns:a16="http://schemas.microsoft.com/office/drawing/2014/main" id="{F1B0724D-6AC8-711C-5D63-B5A8D6DB52D6}"/>
+          <p:cNvPr id="5" name="Footer Placeholder 4">
+            <a:extLst>
+              <a:ext uri="{FF2B5EF4-FFF2-40B4-BE49-F238E27FC236}">
+                <a16:creationId xmlns:a16="http://schemas.microsoft.com/office/drawing/2014/main" id="{A4840508-BDEA-686B-E72C-F616BD6007D1}"/>
               </a:ext>
             </a:extLst>
           </p:cNvPr>
@@ -1166,10 +1175,10 @@
       </p:sp>
       <p:sp>
         <p:nvSpPr>
-          <p:cNvPr id="6" name="Номер слайда 5">
-            <a:extLst>
-              <a:ext uri="{FF2B5EF4-FFF2-40B4-BE49-F238E27FC236}">
-                <a16:creationId xmlns:a16="http://schemas.microsoft.com/office/drawing/2014/main" id="{10FEFA58-9B69-E833-0F8C-5A6366378F9E}"/>
+          <p:cNvPr id="6" name="Slide Number Placeholder 5">
+            <a:extLst>
+              <a:ext uri="{FF2B5EF4-FFF2-40B4-BE49-F238E27FC236}">
+                <a16:creationId xmlns:a16="http://schemas.microsoft.com/office/drawing/2014/main" id="{F9B9BCFC-F19A-BE7A-6757-6B77D3FF6944}"/>
               </a:ext>
             </a:extLst>
           </p:cNvPr>
@@ -1185,7 +1194,7 @@
           <a:bodyPr/>
           <a:lstStyle/>
           <a:p>
-            <a:fld id="{42D7F972-A93D-42B4-85D0-25743E08EB40}" type="slidenum">
+            <a:fld id="{20CA96BB-6BF3-4E52-BE21-7A7A15C0727C}" type="slidenum">
               <a:rPr lang="ru-RU" smtClean="0"/>
               <a:t>‹#›</a:t>
             </a:fld>
@@ -1196,7 +1205,7 @@
     </p:spTree>
     <p:extLst>
       <p:ext uri="{BB962C8B-B14F-4D97-AF65-F5344CB8AC3E}">
-        <p14:creationId xmlns:p14="http://schemas.microsoft.com/office/powerpoint/2010/main" val="815198118"/>
+        <p14:creationId xmlns:p14="http://schemas.microsoft.com/office/powerpoint/2010/main" val="1325099766"/>
       </p:ext>
     </p:extLst>
   </p:cSld>
@@ -1208,7 +1217,7 @@
 
 <file path=ppt/slideLayouts/slideLayout4.xml><?xml version="1.0" encoding="utf-8"?>
 <p:sldLayout xmlns:a="http://schemas.openxmlformats.org/drawingml/2006/main" xmlns:r="http://schemas.openxmlformats.org/officeDocument/2006/relationships" xmlns:p="http://schemas.openxmlformats.org/presentationml/2006/main" type="twoObj" preserve="1">
-  <p:cSld name="Два объекта">
+  <p:cSld name="Two Content">
     <p:spTree>
       <p:nvGrpSpPr>
         <p:cNvPr id="1" name=""/>
@@ -1225,10 +1234,10 @@
       </p:grpSpPr>
       <p:sp>
         <p:nvSpPr>
-          <p:cNvPr id="2" name="Заголовок 1">
-            <a:extLst>
-              <a:ext uri="{FF2B5EF4-FFF2-40B4-BE49-F238E27FC236}">
-                <a16:creationId xmlns:a16="http://schemas.microsoft.com/office/drawing/2014/main" id="{F1D4A87D-9B60-6DA9-F2A4-3351B0257557}"/>
+          <p:cNvPr id="2" name="Title 1">
+            <a:extLst>
+              <a:ext uri="{FF2B5EF4-FFF2-40B4-BE49-F238E27FC236}">
+                <a16:creationId xmlns:a16="http://schemas.microsoft.com/office/drawing/2014/main" id="{9B0213EA-2534-745B-7805-4D5973E7F5EB}"/>
               </a:ext>
             </a:extLst>
           </p:cNvPr>
@@ -1245,18 +1254,19 @@
           <a:lstStyle/>
           <a:p>
             <a:r>
-              <a:rPr lang="ru-RU"/>
-              <a:t>Образец заголовка</a:t>
-            </a:r>
-          </a:p>
-        </p:txBody>
-      </p:sp>
-      <p:sp>
-        <p:nvSpPr>
-          <p:cNvPr id="3" name="Объект 2">
-            <a:extLst>
-              <a:ext uri="{FF2B5EF4-FFF2-40B4-BE49-F238E27FC236}">
-                <a16:creationId xmlns:a16="http://schemas.microsoft.com/office/drawing/2014/main" id="{515C57DE-BA02-BC54-BAD7-C66307736AD2}"/>
+              <a:rPr lang="en-US"/>
+              <a:t>Click to edit Master title style</a:t>
+            </a:r>
+            <a:endParaRPr lang="ru-RU"/>
+          </a:p>
+        </p:txBody>
+      </p:sp>
+      <p:sp>
+        <p:nvSpPr>
+          <p:cNvPr id="3" name="Content Placeholder 2">
+            <a:extLst>
+              <a:ext uri="{FF2B5EF4-FFF2-40B4-BE49-F238E27FC236}">
+                <a16:creationId xmlns:a16="http://schemas.microsoft.com/office/drawing/2014/main" id="{4BA18873-9F4C-5A24-D9A0-B6FDFB7C7AA6}"/>
               </a:ext>
             </a:extLst>
           </p:cNvPr>
@@ -1279,46 +1289,47 @@
           <a:p>
             <a:pPr lvl="0"/>
             <a:r>
-              <a:rPr lang="ru-RU"/>
-              <a:t>Образец текста</a:t>
+              <a:rPr lang="en-US"/>
+              <a:t>Click to edit Master text styles</a:t>
             </a:r>
           </a:p>
           <a:p>
             <a:pPr lvl="1"/>
             <a:r>
-              <a:rPr lang="ru-RU"/>
-              <a:t>Второй уровень</a:t>
+              <a:rPr lang="en-US"/>
+              <a:t>Second level</a:t>
             </a:r>
           </a:p>
           <a:p>
             <a:pPr lvl="2"/>
             <a:r>
-              <a:rPr lang="ru-RU"/>
-              <a:t>Третий уровень</a:t>
+              <a:rPr lang="en-US"/>
+              <a:t>Third level</a:t>
             </a:r>
           </a:p>
           <a:p>
             <a:pPr lvl="3"/>
             <a:r>
-              <a:rPr lang="ru-RU"/>
-              <a:t>Четвертый уровень</a:t>
+              <a:rPr lang="en-US"/>
+              <a:t>Fourth level</a:t>
             </a:r>
           </a:p>
           <a:p>
             <a:pPr lvl="4"/>
             <a:r>
-              <a:rPr lang="ru-RU"/>
-              <a:t>Пятый уровень</a:t>
-            </a:r>
-          </a:p>
-        </p:txBody>
-      </p:sp>
-      <p:sp>
-        <p:nvSpPr>
-          <p:cNvPr id="4" name="Объект 3">
-            <a:extLst>
-              <a:ext uri="{FF2B5EF4-FFF2-40B4-BE49-F238E27FC236}">
-                <a16:creationId xmlns:a16="http://schemas.microsoft.com/office/drawing/2014/main" id="{9BEC0597-A5C6-3862-34D0-AED92EFDEE37}"/>
+              <a:rPr lang="en-US"/>
+              <a:t>Fifth level</a:t>
+            </a:r>
+            <a:endParaRPr lang="ru-RU"/>
+          </a:p>
+        </p:txBody>
+      </p:sp>
+      <p:sp>
+        <p:nvSpPr>
+          <p:cNvPr id="4" name="Content Placeholder 3">
+            <a:extLst>
+              <a:ext uri="{FF2B5EF4-FFF2-40B4-BE49-F238E27FC236}">
+                <a16:creationId xmlns:a16="http://schemas.microsoft.com/office/drawing/2014/main" id="{24165C14-C943-1EDF-AE11-F83DB670709E}"/>
               </a:ext>
             </a:extLst>
           </p:cNvPr>
@@ -1341,46 +1352,47 @@
           <a:p>
             <a:pPr lvl="0"/>
             <a:r>
-              <a:rPr lang="ru-RU"/>
-              <a:t>Образец текста</a:t>
+              <a:rPr lang="en-US"/>
+              <a:t>Click to edit Master text styles</a:t>
             </a:r>
           </a:p>
           <a:p>
             <a:pPr lvl="1"/>
             <a:r>
-              <a:rPr lang="ru-RU"/>
-              <a:t>Второй уровень</a:t>
+              <a:rPr lang="en-US"/>
+              <a:t>Second level</a:t>
             </a:r>
           </a:p>
           <a:p>
             <a:pPr lvl="2"/>
             <a:r>
-              <a:rPr lang="ru-RU"/>
-              <a:t>Третий уровень</a:t>
+              <a:rPr lang="en-US"/>
+              <a:t>Third level</a:t>
             </a:r>
           </a:p>
           <a:p>
             <a:pPr lvl="3"/>
             <a:r>
-              <a:rPr lang="ru-RU"/>
-              <a:t>Четвертый уровень</a:t>
+              <a:rPr lang="en-US"/>
+              <a:t>Fourth level</a:t>
             </a:r>
           </a:p>
           <a:p>
             <a:pPr lvl="4"/>
             <a:r>
-              <a:rPr lang="ru-RU"/>
-              <a:t>Пятый уровень</a:t>
-            </a:r>
-          </a:p>
-        </p:txBody>
-      </p:sp>
-      <p:sp>
-        <p:nvSpPr>
-          <p:cNvPr id="5" name="Дата 4">
-            <a:extLst>
-              <a:ext uri="{FF2B5EF4-FFF2-40B4-BE49-F238E27FC236}">
-                <a16:creationId xmlns:a16="http://schemas.microsoft.com/office/drawing/2014/main" id="{14EA6B28-100B-2B9E-8A76-30D42876E714}"/>
+              <a:rPr lang="en-US"/>
+              <a:t>Fifth level</a:t>
+            </a:r>
+            <a:endParaRPr lang="ru-RU"/>
+          </a:p>
+        </p:txBody>
+      </p:sp>
+      <p:sp>
+        <p:nvSpPr>
+          <p:cNvPr id="5" name="Date Placeholder 4">
+            <a:extLst>
+              <a:ext uri="{FF2B5EF4-FFF2-40B4-BE49-F238E27FC236}">
+                <a16:creationId xmlns:a16="http://schemas.microsoft.com/office/drawing/2014/main" id="{69D0F60F-7DA6-8187-A845-43B4E800E38A}"/>
               </a:ext>
             </a:extLst>
           </p:cNvPr>
@@ -1396,9 +1408,9 @@
           <a:bodyPr/>
           <a:lstStyle/>
           <a:p>
-            <a:fld id="{9757B1A7-0FDC-40C9-B67F-A43EAC5AEB09}" type="datetimeFigureOut">
+            <a:fld id="{961A2009-0CEE-41C1-939A-B9C723B78133}" type="datetimeFigureOut">
               <a:rPr lang="ru-RU" smtClean="0"/>
-              <a:t>04.02.2026</a:t>
+              <a:t>05.03.2026</a:t>
             </a:fld>
             <a:endParaRPr lang="ru-RU"/>
           </a:p>
@@ -1406,10 +1418,10 @@
       </p:sp>
       <p:sp>
         <p:nvSpPr>
-          <p:cNvPr id="6" name="Нижний колонтитул 5">
-            <a:extLst>
-              <a:ext uri="{FF2B5EF4-FFF2-40B4-BE49-F238E27FC236}">
-                <a16:creationId xmlns:a16="http://schemas.microsoft.com/office/drawing/2014/main" id="{F956932B-7917-729F-C148-CABF497E05FC}"/>
+          <p:cNvPr id="6" name="Footer Placeholder 5">
+            <a:extLst>
+              <a:ext uri="{FF2B5EF4-FFF2-40B4-BE49-F238E27FC236}">
+                <a16:creationId xmlns:a16="http://schemas.microsoft.com/office/drawing/2014/main" id="{AF5A37D8-4789-662D-0DDA-8015F9B7DA7E}"/>
               </a:ext>
             </a:extLst>
           </p:cNvPr>
@@ -1431,10 +1443,10 @@
       </p:sp>
       <p:sp>
         <p:nvSpPr>
-          <p:cNvPr id="7" name="Номер слайда 6">
-            <a:extLst>
-              <a:ext uri="{FF2B5EF4-FFF2-40B4-BE49-F238E27FC236}">
-                <a16:creationId xmlns:a16="http://schemas.microsoft.com/office/drawing/2014/main" id="{9ABB5D29-A9DE-B121-432A-EC1C4CE9670B}"/>
+          <p:cNvPr id="7" name="Slide Number Placeholder 6">
+            <a:extLst>
+              <a:ext uri="{FF2B5EF4-FFF2-40B4-BE49-F238E27FC236}">
+                <a16:creationId xmlns:a16="http://schemas.microsoft.com/office/drawing/2014/main" id="{05E44BFF-EBA6-8471-7A6F-2D2102FBAD19}"/>
               </a:ext>
             </a:extLst>
           </p:cNvPr>
@@ -1450,7 +1462,7 @@
           <a:bodyPr/>
           <a:lstStyle/>
           <a:p>
-            <a:fld id="{42D7F972-A93D-42B4-85D0-25743E08EB40}" type="slidenum">
+            <a:fld id="{20CA96BB-6BF3-4E52-BE21-7A7A15C0727C}" type="slidenum">
               <a:rPr lang="ru-RU" smtClean="0"/>
               <a:t>‹#›</a:t>
             </a:fld>
@@ -1461,7 +1473,7 @@
     </p:spTree>
     <p:extLst>
       <p:ext uri="{BB962C8B-B14F-4D97-AF65-F5344CB8AC3E}">
-        <p14:creationId xmlns:p14="http://schemas.microsoft.com/office/powerpoint/2010/main" val="1928279250"/>
+        <p14:creationId xmlns:p14="http://schemas.microsoft.com/office/powerpoint/2010/main" val="4173801008"/>
       </p:ext>
     </p:extLst>
   </p:cSld>
@@ -1473,7 +1485,7 @@
 
 <file path=ppt/slideLayouts/slideLayout5.xml><?xml version="1.0" encoding="utf-8"?>
 <p:sldLayout xmlns:a="http://schemas.openxmlformats.org/drawingml/2006/main" xmlns:r="http://schemas.openxmlformats.org/officeDocument/2006/relationships" xmlns:p="http://schemas.openxmlformats.org/presentationml/2006/main" type="twoTxTwoObj" preserve="1">
-  <p:cSld name="Сравнение">
+  <p:cSld name="Comparison">
     <p:spTree>
       <p:nvGrpSpPr>
         <p:cNvPr id="1" name=""/>
@@ -1490,10 +1502,10 @@
       </p:grpSpPr>
       <p:sp>
         <p:nvSpPr>
-          <p:cNvPr id="2" name="Заголовок 1">
-            <a:extLst>
-              <a:ext uri="{FF2B5EF4-FFF2-40B4-BE49-F238E27FC236}">
-                <a16:creationId xmlns:a16="http://schemas.microsoft.com/office/drawing/2014/main" id="{99675336-39E1-1BB1-09E8-2E1FAC6BC997}"/>
+          <p:cNvPr id="2" name="Title 1">
+            <a:extLst>
+              <a:ext uri="{FF2B5EF4-FFF2-40B4-BE49-F238E27FC236}">
+                <a16:creationId xmlns:a16="http://schemas.microsoft.com/office/drawing/2014/main" id="{4F6F7693-190A-A378-9238-28EC886E1F2E}"/>
               </a:ext>
             </a:extLst>
           </p:cNvPr>
@@ -1515,18 +1527,19 @@
           <a:lstStyle/>
           <a:p>
             <a:r>
-              <a:rPr lang="ru-RU"/>
-              <a:t>Образец заголовка</a:t>
-            </a:r>
-          </a:p>
-        </p:txBody>
-      </p:sp>
-      <p:sp>
-        <p:nvSpPr>
-          <p:cNvPr id="3" name="Текст 2">
-            <a:extLst>
-              <a:ext uri="{FF2B5EF4-FFF2-40B4-BE49-F238E27FC236}">
-                <a16:creationId xmlns:a16="http://schemas.microsoft.com/office/drawing/2014/main" id="{65D2D848-D6B9-16F3-CD9E-548A9BB3007F}"/>
+              <a:rPr lang="en-US"/>
+              <a:t>Click to edit Master title style</a:t>
+            </a:r>
+            <a:endParaRPr lang="ru-RU"/>
+          </a:p>
+        </p:txBody>
+      </p:sp>
+      <p:sp>
+        <p:nvSpPr>
+          <p:cNvPr id="3" name="Text Placeholder 2">
+            <a:extLst>
+              <a:ext uri="{FF2B5EF4-FFF2-40B4-BE49-F238E27FC236}">
+                <a16:creationId xmlns:a16="http://schemas.microsoft.com/office/drawing/2014/main" id="{89354090-B2A4-2933-5A31-E21B6DC18FA9}"/>
               </a:ext>
             </a:extLst>
           </p:cNvPr>
@@ -1586,18 +1599,18 @@
           <a:p>
             <a:pPr lvl="0"/>
             <a:r>
-              <a:rPr lang="ru-RU"/>
-              <a:t>Образец текста</a:t>
-            </a:r>
-          </a:p>
-        </p:txBody>
-      </p:sp>
-      <p:sp>
-        <p:nvSpPr>
-          <p:cNvPr id="4" name="Объект 3">
-            <a:extLst>
-              <a:ext uri="{FF2B5EF4-FFF2-40B4-BE49-F238E27FC236}">
-                <a16:creationId xmlns:a16="http://schemas.microsoft.com/office/drawing/2014/main" id="{6D0D674D-597E-74B8-8EB8-27AFA87A2DF5}"/>
+              <a:rPr lang="en-US"/>
+              <a:t>Click to edit Master text styles</a:t>
+            </a:r>
+          </a:p>
+        </p:txBody>
+      </p:sp>
+      <p:sp>
+        <p:nvSpPr>
+          <p:cNvPr id="4" name="Content Placeholder 3">
+            <a:extLst>
+              <a:ext uri="{FF2B5EF4-FFF2-40B4-BE49-F238E27FC236}">
+                <a16:creationId xmlns:a16="http://schemas.microsoft.com/office/drawing/2014/main" id="{B428248F-7DCC-908D-C2C6-4971EE5B70B1}"/>
               </a:ext>
             </a:extLst>
           </p:cNvPr>
@@ -1620,46 +1633,47 @@
           <a:p>
             <a:pPr lvl="0"/>
             <a:r>
-              <a:rPr lang="ru-RU"/>
-              <a:t>Образец текста</a:t>
+              <a:rPr lang="en-US"/>
+              <a:t>Click to edit Master text styles</a:t>
             </a:r>
           </a:p>
           <a:p>
             <a:pPr lvl="1"/>
             <a:r>
-              <a:rPr lang="ru-RU"/>
-              <a:t>Второй уровень</a:t>
+              <a:rPr lang="en-US"/>
+              <a:t>Second level</a:t>
             </a:r>
           </a:p>
           <a:p>
             <a:pPr lvl="2"/>
             <a:r>
-              <a:rPr lang="ru-RU"/>
-              <a:t>Третий уровень</a:t>
+              <a:rPr lang="en-US"/>
+              <a:t>Third level</a:t>
             </a:r>
           </a:p>
           <a:p>
             <a:pPr lvl="3"/>
             <a:r>
-              <a:rPr lang="ru-RU"/>
-              <a:t>Четвертый уровень</a:t>
+              <a:rPr lang="en-US"/>
+              <a:t>Fourth level</a:t>
             </a:r>
           </a:p>
           <a:p>
             <a:pPr lvl="4"/>
             <a:r>
-              <a:rPr lang="ru-RU"/>
-              <a:t>Пятый уровень</a:t>
-            </a:r>
-          </a:p>
-        </p:txBody>
-      </p:sp>
-      <p:sp>
-        <p:nvSpPr>
-          <p:cNvPr id="5" name="Текст 4">
-            <a:extLst>
-              <a:ext uri="{FF2B5EF4-FFF2-40B4-BE49-F238E27FC236}">
-                <a16:creationId xmlns:a16="http://schemas.microsoft.com/office/drawing/2014/main" id="{01529850-F0ED-0EC8-2CCD-2B56C7F316C9}"/>
+              <a:rPr lang="en-US"/>
+              <a:t>Fifth level</a:t>
+            </a:r>
+            <a:endParaRPr lang="ru-RU"/>
+          </a:p>
+        </p:txBody>
+      </p:sp>
+      <p:sp>
+        <p:nvSpPr>
+          <p:cNvPr id="5" name="Text Placeholder 4">
+            <a:extLst>
+              <a:ext uri="{FF2B5EF4-FFF2-40B4-BE49-F238E27FC236}">
+                <a16:creationId xmlns:a16="http://schemas.microsoft.com/office/drawing/2014/main" id="{4DB42156-7316-0013-53E3-218ACA8ED92F}"/>
               </a:ext>
             </a:extLst>
           </p:cNvPr>
@@ -1719,18 +1733,18 @@
           <a:p>
             <a:pPr lvl="0"/>
             <a:r>
-              <a:rPr lang="ru-RU"/>
-              <a:t>Образец текста</a:t>
-            </a:r>
-          </a:p>
-        </p:txBody>
-      </p:sp>
-      <p:sp>
-        <p:nvSpPr>
-          <p:cNvPr id="6" name="Объект 5">
-            <a:extLst>
-              <a:ext uri="{FF2B5EF4-FFF2-40B4-BE49-F238E27FC236}">
-                <a16:creationId xmlns:a16="http://schemas.microsoft.com/office/drawing/2014/main" id="{3C7837AB-929D-E85F-169A-650F2B2EFB99}"/>
+              <a:rPr lang="en-US"/>
+              <a:t>Click to edit Master text styles</a:t>
+            </a:r>
+          </a:p>
+        </p:txBody>
+      </p:sp>
+      <p:sp>
+        <p:nvSpPr>
+          <p:cNvPr id="6" name="Content Placeholder 5">
+            <a:extLst>
+              <a:ext uri="{FF2B5EF4-FFF2-40B4-BE49-F238E27FC236}">
+                <a16:creationId xmlns:a16="http://schemas.microsoft.com/office/drawing/2014/main" id="{E04B6884-63EB-0572-0BFD-FC66C82E7DF3}"/>
               </a:ext>
             </a:extLst>
           </p:cNvPr>
@@ -1753,46 +1767,47 @@
           <a:p>
             <a:pPr lvl="0"/>
             <a:r>
-              <a:rPr lang="ru-RU"/>
-              <a:t>Образец текста</a:t>
+              <a:rPr lang="en-US"/>
+              <a:t>Click to edit Master text styles</a:t>
             </a:r>
           </a:p>
           <a:p>
             <a:pPr lvl="1"/>
             <a:r>
-              <a:rPr lang="ru-RU"/>
-              <a:t>Второй уровень</a:t>
+              <a:rPr lang="en-US"/>
+              <a:t>Second level</a:t>
             </a:r>
           </a:p>
           <a:p>
             <a:pPr lvl="2"/>
             <a:r>
-              <a:rPr lang="ru-RU"/>
-              <a:t>Третий уровень</a:t>
+              <a:rPr lang="en-US"/>
+              <a:t>Third level</a:t>
             </a:r>
           </a:p>
           <a:p>
             <a:pPr lvl="3"/>
             <a:r>
-              <a:rPr lang="ru-RU"/>
-              <a:t>Четвертый уровень</a:t>
+              <a:rPr lang="en-US"/>
+              <a:t>Fourth level</a:t>
             </a:r>
           </a:p>
           <a:p>
             <a:pPr lvl="4"/>
             <a:r>
-              <a:rPr lang="ru-RU"/>
-              <a:t>Пятый уровень</a:t>
-            </a:r>
-          </a:p>
-        </p:txBody>
-      </p:sp>
-      <p:sp>
-        <p:nvSpPr>
-          <p:cNvPr id="7" name="Дата 6">
-            <a:extLst>
-              <a:ext uri="{FF2B5EF4-FFF2-40B4-BE49-F238E27FC236}">
-                <a16:creationId xmlns:a16="http://schemas.microsoft.com/office/drawing/2014/main" id="{457E9C33-88D9-AA70-62CB-62A36B38A170}"/>
+              <a:rPr lang="en-US"/>
+              <a:t>Fifth level</a:t>
+            </a:r>
+            <a:endParaRPr lang="ru-RU"/>
+          </a:p>
+        </p:txBody>
+      </p:sp>
+      <p:sp>
+        <p:nvSpPr>
+          <p:cNvPr id="7" name="Date Placeholder 6">
+            <a:extLst>
+              <a:ext uri="{FF2B5EF4-FFF2-40B4-BE49-F238E27FC236}">
+                <a16:creationId xmlns:a16="http://schemas.microsoft.com/office/drawing/2014/main" id="{5AC6917B-B64D-AD9E-1D30-A157734E84AC}"/>
               </a:ext>
             </a:extLst>
           </p:cNvPr>
@@ -1808,9 +1823,9 @@
           <a:bodyPr/>
           <a:lstStyle/>
           <a:p>
-            <a:fld id="{9757B1A7-0FDC-40C9-B67F-A43EAC5AEB09}" type="datetimeFigureOut">
+            <a:fld id="{961A2009-0CEE-41C1-939A-B9C723B78133}" type="datetimeFigureOut">
               <a:rPr lang="ru-RU" smtClean="0"/>
-              <a:t>04.02.2026</a:t>
+              <a:t>05.03.2026</a:t>
             </a:fld>
             <a:endParaRPr lang="ru-RU"/>
           </a:p>
@@ -1818,10 +1833,10 @@
       </p:sp>
       <p:sp>
         <p:nvSpPr>
-          <p:cNvPr id="8" name="Нижний колонтитул 7">
-            <a:extLst>
-              <a:ext uri="{FF2B5EF4-FFF2-40B4-BE49-F238E27FC236}">
-                <a16:creationId xmlns:a16="http://schemas.microsoft.com/office/drawing/2014/main" id="{382CCA61-2F55-EB02-FBF0-8C2B0ED263DD}"/>
+          <p:cNvPr id="8" name="Footer Placeholder 7">
+            <a:extLst>
+              <a:ext uri="{FF2B5EF4-FFF2-40B4-BE49-F238E27FC236}">
+                <a16:creationId xmlns:a16="http://schemas.microsoft.com/office/drawing/2014/main" id="{C475AFC1-84B5-54AD-7B42-F8B861602F11}"/>
               </a:ext>
             </a:extLst>
           </p:cNvPr>
@@ -1843,10 +1858,10 @@
       </p:sp>
       <p:sp>
         <p:nvSpPr>
-          <p:cNvPr id="9" name="Номер слайда 8">
-            <a:extLst>
-              <a:ext uri="{FF2B5EF4-FFF2-40B4-BE49-F238E27FC236}">
-                <a16:creationId xmlns:a16="http://schemas.microsoft.com/office/drawing/2014/main" id="{EA67DF5A-C355-F235-AD31-EB1F5FB62FC8}"/>
+          <p:cNvPr id="9" name="Slide Number Placeholder 8">
+            <a:extLst>
+              <a:ext uri="{FF2B5EF4-FFF2-40B4-BE49-F238E27FC236}">
+                <a16:creationId xmlns:a16="http://schemas.microsoft.com/office/drawing/2014/main" id="{6B694659-38AE-93FF-6C9D-043A11F97CA0}"/>
               </a:ext>
             </a:extLst>
           </p:cNvPr>
@@ -1862,7 +1877,7 @@
           <a:bodyPr/>
           <a:lstStyle/>
           <a:p>
-            <a:fld id="{42D7F972-A93D-42B4-85D0-25743E08EB40}" type="slidenum">
+            <a:fld id="{20CA96BB-6BF3-4E52-BE21-7A7A15C0727C}" type="slidenum">
               <a:rPr lang="ru-RU" smtClean="0"/>
               <a:t>‹#›</a:t>
             </a:fld>
@@ -1873,7 +1888,7 @@
     </p:spTree>
     <p:extLst>
       <p:ext uri="{BB962C8B-B14F-4D97-AF65-F5344CB8AC3E}">
-        <p14:creationId xmlns:p14="http://schemas.microsoft.com/office/powerpoint/2010/main" val="2155574911"/>
+        <p14:creationId xmlns:p14="http://schemas.microsoft.com/office/powerpoint/2010/main" val="1514139868"/>
       </p:ext>
     </p:extLst>
   </p:cSld>
@@ -1885,7 +1900,7 @@
 
 <file path=ppt/slideLayouts/slideLayout6.xml><?xml version="1.0" encoding="utf-8"?>
 <p:sldLayout xmlns:a="http://schemas.openxmlformats.org/drawingml/2006/main" xmlns:r="http://schemas.openxmlformats.org/officeDocument/2006/relationships" xmlns:p="http://schemas.openxmlformats.org/presentationml/2006/main" type="titleOnly" preserve="1">
-  <p:cSld name="Только заголовок">
+  <p:cSld name="Title Only">
     <p:spTree>
       <p:nvGrpSpPr>
         <p:cNvPr id="1" name=""/>
@@ -1902,10 +1917,10 @@
       </p:grpSpPr>
       <p:sp>
         <p:nvSpPr>
-          <p:cNvPr id="2" name="Заголовок 1">
-            <a:extLst>
-              <a:ext uri="{FF2B5EF4-FFF2-40B4-BE49-F238E27FC236}">
-                <a16:creationId xmlns:a16="http://schemas.microsoft.com/office/drawing/2014/main" id="{9DCEAC0E-7FD4-5CD7-5A5C-381338074F84}"/>
+          <p:cNvPr id="2" name="Title 1">
+            <a:extLst>
+              <a:ext uri="{FF2B5EF4-FFF2-40B4-BE49-F238E27FC236}">
+                <a16:creationId xmlns:a16="http://schemas.microsoft.com/office/drawing/2014/main" id="{D9978ABC-9069-BEAD-AD0A-34F60467E8A4}"/>
               </a:ext>
             </a:extLst>
           </p:cNvPr>
@@ -1922,18 +1937,19 @@
           <a:lstStyle/>
           <a:p>
             <a:r>
-              <a:rPr lang="ru-RU"/>
-              <a:t>Образец заголовка</a:t>
-            </a:r>
-          </a:p>
-        </p:txBody>
-      </p:sp>
-      <p:sp>
-        <p:nvSpPr>
-          <p:cNvPr id="3" name="Дата 2">
-            <a:extLst>
-              <a:ext uri="{FF2B5EF4-FFF2-40B4-BE49-F238E27FC236}">
-                <a16:creationId xmlns:a16="http://schemas.microsoft.com/office/drawing/2014/main" id="{DFE282B0-E6C5-621D-B9CC-C0DF4308A152}"/>
+              <a:rPr lang="en-US"/>
+              <a:t>Click to edit Master title style</a:t>
+            </a:r>
+            <a:endParaRPr lang="ru-RU"/>
+          </a:p>
+        </p:txBody>
+      </p:sp>
+      <p:sp>
+        <p:nvSpPr>
+          <p:cNvPr id="3" name="Date Placeholder 2">
+            <a:extLst>
+              <a:ext uri="{FF2B5EF4-FFF2-40B4-BE49-F238E27FC236}">
+                <a16:creationId xmlns:a16="http://schemas.microsoft.com/office/drawing/2014/main" id="{27F88149-3EF5-F555-9EED-CB444DA1AD96}"/>
               </a:ext>
             </a:extLst>
           </p:cNvPr>
@@ -1949,9 +1965,9 @@
           <a:bodyPr/>
           <a:lstStyle/>
           <a:p>
-            <a:fld id="{9757B1A7-0FDC-40C9-B67F-A43EAC5AEB09}" type="datetimeFigureOut">
+            <a:fld id="{961A2009-0CEE-41C1-939A-B9C723B78133}" type="datetimeFigureOut">
               <a:rPr lang="ru-RU" smtClean="0"/>
-              <a:t>04.02.2026</a:t>
+              <a:t>05.03.2026</a:t>
             </a:fld>
             <a:endParaRPr lang="ru-RU"/>
           </a:p>
@@ -1959,10 +1975,10 @@
       </p:sp>
       <p:sp>
         <p:nvSpPr>
-          <p:cNvPr id="4" name="Нижний колонтитул 3">
-            <a:extLst>
-              <a:ext uri="{FF2B5EF4-FFF2-40B4-BE49-F238E27FC236}">
-                <a16:creationId xmlns:a16="http://schemas.microsoft.com/office/drawing/2014/main" id="{4642812F-0AC4-C0D1-5767-10E867ACF1D2}"/>
+          <p:cNvPr id="4" name="Footer Placeholder 3">
+            <a:extLst>
+              <a:ext uri="{FF2B5EF4-FFF2-40B4-BE49-F238E27FC236}">
+                <a16:creationId xmlns:a16="http://schemas.microsoft.com/office/drawing/2014/main" id="{8E021061-3292-CA9C-F704-E572ED84C172}"/>
               </a:ext>
             </a:extLst>
           </p:cNvPr>
@@ -1984,10 +2000,10 @@
       </p:sp>
       <p:sp>
         <p:nvSpPr>
-          <p:cNvPr id="5" name="Номер слайда 4">
-            <a:extLst>
-              <a:ext uri="{FF2B5EF4-FFF2-40B4-BE49-F238E27FC236}">
-                <a16:creationId xmlns:a16="http://schemas.microsoft.com/office/drawing/2014/main" id="{E781B209-06AA-9531-C26F-07E6335986E0}"/>
+          <p:cNvPr id="5" name="Slide Number Placeholder 4">
+            <a:extLst>
+              <a:ext uri="{FF2B5EF4-FFF2-40B4-BE49-F238E27FC236}">
+                <a16:creationId xmlns:a16="http://schemas.microsoft.com/office/drawing/2014/main" id="{6C8A62FB-F613-FD33-C235-7459BDB6FB76}"/>
               </a:ext>
             </a:extLst>
           </p:cNvPr>
@@ -2003,7 +2019,7 @@
           <a:bodyPr/>
           <a:lstStyle/>
           <a:p>
-            <a:fld id="{42D7F972-A93D-42B4-85D0-25743E08EB40}" type="slidenum">
+            <a:fld id="{20CA96BB-6BF3-4E52-BE21-7A7A15C0727C}" type="slidenum">
               <a:rPr lang="ru-RU" smtClean="0"/>
               <a:t>‹#›</a:t>
             </a:fld>
@@ -2014,7 +2030,7 @@
     </p:spTree>
     <p:extLst>
       <p:ext uri="{BB962C8B-B14F-4D97-AF65-F5344CB8AC3E}">
-        <p14:creationId xmlns:p14="http://schemas.microsoft.com/office/powerpoint/2010/main" val="541983718"/>
+        <p14:creationId xmlns:p14="http://schemas.microsoft.com/office/powerpoint/2010/main" val="3449250592"/>
       </p:ext>
     </p:extLst>
   </p:cSld>
@@ -2026,7 +2042,7 @@
 
 <file path=ppt/slideLayouts/slideLayout7.xml><?xml version="1.0" encoding="utf-8"?>
 <p:sldLayout xmlns:a="http://schemas.openxmlformats.org/drawingml/2006/main" xmlns:r="http://schemas.openxmlformats.org/officeDocument/2006/relationships" xmlns:p="http://schemas.openxmlformats.org/presentationml/2006/main" type="blank" preserve="1">
-  <p:cSld name="Пустой слайд">
+  <p:cSld name="Blank">
     <p:spTree>
       <p:nvGrpSpPr>
         <p:cNvPr id="1" name=""/>
@@ -2043,10 +2059,10 @@
       </p:grpSpPr>
       <p:sp>
         <p:nvSpPr>
-          <p:cNvPr id="2" name="Дата 1">
-            <a:extLst>
-              <a:ext uri="{FF2B5EF4-FFF2-40B4-BE49-F238E27FC236}">
-                <a16:creationId xmlns:a16="http://schemas.microsoft.com/office/drawing/2014/main" id="{8C49B1D8-DE00-2FFB-526C-B4D63ED63AB4}"/>
+          <p:cNvPr id="2" name="Date Placeholder 1">
+            <a:extLst>
+              <a:ext uri="{FF2B5EF4-FFF2-40B4-BE49-F238E27FC236}">
+                <a16:creationId xmlns:a16="http://schemas.microsoft.com/office/drawing/2014/main" id="{15E2D87C-C9C1-F1BD-DE5E-1824814F97CE}"/>
               </a:ext>
             </a:extLst>
           </p:cNvPr>
@@ -2062,9 +2078,9 @@
           <a:bodyPr/>
           <a:lstStyle/>
           <a:p>
-            <a:fld id="{9757B1A7-0FDC-40C9-B67F-A43EAC5AEB09}" type="datetimeFigureOut">
+            <a:fld id="{961A2009-0CEE-41C1-939A-B9C723B78133}" type="datetimeFigureOut">
               <a:rPr lang="ru-RU" smtClean="0"/>
-              <a:t>04.02.2026</a:t>
+              <a:t>05.03.2026</a:t>
             </a:fld>
             <a:endParaRPr lang="ru-RU"/>
           </a:p>
@@ -2072,10 +2088,10 @@
       </p:sp>
       <p:sp>
         <p:nvSpPr>
-          <p:cNvPr id="3" name="Нижний колонтитул 2">
-            <a:extLst>
-              <a:ext uri="{FF2B5EF4-FFF2-40B4-BE49-F238E27FC236}">
-                <a16:creationId xmlns:a16="http://schemas.microsoft.com/office/drawing/2014/main" id="{55CED67F-C84E-E571-2C38-7483901106DD}"/>
+          <p:cNvPr id="3" name="Footer Placeholder 2">
+            <a:extLst>
+              <a:ext uri="{FF2B5EF4-FFF2-40B4-BE49-F238E27FC236}">
+                <a16:creationId xmlns:a16="http://schemas.microsoft.com/office/drawing/2014/main" id="{C016AB82-3AC5-25F1-266E-AFF429C9D810}"/>
               </a:ext>
             </a:extLst>
           </p:cNvPr>
@@ -2097,10 +2113,10 @@
       </p:sp>
       <p:sp>
         <p:nvSpPr>
-          <p:cNvPr id="4" name="Номер слайда 3">
-            <a:extLst>
-              <a:ext uri="{FF2B5EF4-FFF2-40B4-BE49-F238E27FC236}">
-                <a16:creationId xmlns:a16="http://schemas.microsoft.com/office/drawing/2014/main" id="{C40F3371-D2FE-581D-5991-08C4E8ABB40D}"/>
+          <p:cNvPr id="4" name="Slide Number Placeholder 3">
+            <a:extLst>
+              <a:ext uri="{FF2B5EF4-FFF2-40B4-BE49-F238E27FC236}">
+                <a16:creationId xmlns:a16="http://schemas.microsoft.com/office/drawing/2014/main" id="{5423B3A3-EED1-89DC-5D3B-D47C0BB5DC77}"/>
               </a:ext>
             </a:extLst>
           </p:cNvPr>
@@ -2116,7 +2132,7 @@
           <a:bodyPr/>
           <a:lstStyle/>
           <a:p>
-            <a:fld id="{42D7F972-A93D-42B4-85D0-25743E08EB40}" type="slidenum">
+            <a:fld id="{20CA96BB-6BF3-4E52-BE21-7A7A15C0727C}" type="slidenum">
               <a:rPr lang="ru-RU" smtClean="0"/>
               <a:t>‹#›</a:t>
             </a:fld>
@@ -2127,7 +2143,7 @@
     </p:spTree>
     <p:extLst>
       <p:ext uri="{BB962C8B-B14F-4D97-AF65-F5344CB8AC3E}">
-        <p14:creationId xmlns:p14="http://schemas.microsoft.com/office/powerpoint/2010/main" val="441436931"/>
+        <p14:creationId xmlns:p14="http://schemas.microsoft.com/office/powerpoint/2010/main" val="770470271"/>
       </p:ext>
     </p:extLst>
   </p:cSld>
@@ -2139,7 +2155,7 @@
 
 <file path=ppt/slideLayouts/slideLayout8.xml><?xml version="1.0" encoding="utf-8"?>
 <p:sldLayout xmlns:a="http://schemas.openxmlformats.org/drawingml/2006/main" xmlns:r="http://schemas.openxmlformats.org/officeDocument/2006/relationships" xmlns:p="http://schemas.openxmlformats.org/presentationml/2006/main" type="objTx" preserve="1">
-  <p:cSld name="Объект с подписью">
+  <p:cSld name="Content with Caption">
     <p:spTree>
       <p:nvGrpSpPr>
         <p:cNvPr id="1" name=""/>
@@ -2156,10 +2172,10 @@
       </p:grpSpPr>
       <p:sp>
         <p:nvSpPr>
-          <p:cNvPr id="2" name="Заголовок 1">
-            <a:extLst>
-              <a:ext uri="{FF2B5EF4-FFF2-40B4-BE49-F238E27FC236}">
-                <a16:creationId xmlns:a16="http://schemas.microsoft.com/office/drawing/2014/main" id="{1DE27666-E51B-953A-4853-A4286175F271}"/>
+          <p:cNvPr id="2" name="Title 1">
+            <a:extLst>
+              <a:ext uri="{FF2B5EF4-FFF2-40B4-BE49-F238E27FC236}">
+                <a16:creationId xmlns:a16="http://schemas.microsoft.com/office/drawing/2014/main" id="{4CE98681-217C-3CF2-1CBF-83D487A0B2D9}"/>
               </a:ext>
             </a:extLst>
           </p:cNvPr>
@@ -2185,18 +2201,19 @@
           </a:lstStyle>
           <a:p>
             <a:r>
-              <a:rPr lang="ru-RU"/>
-              <a:t>Образец заголовка</a:t>
-            </a:r>
-          </a:p>
-        </p:txBody>
-      </p:sp>
-      <p:sp>
-        <p:nvSpPr>
-          <p:cNvPr id="3" name="Объект 2">
-            <a:extLst>
-              <a:ext uri="{FF2B5EF4-FFF2-40B4-BE49-F238E27FC236}">
-                <a16:creationId xmlns:a16="http://schemas.microsoft.com/office/drawing/2014/main" id="{BCEDB095-477D-36E0-C08E-89CF5A8AEE0A}"/>
+              <a:rPr lang="en-US"/>
+              <a:t>Click to edit Master title style</a:t>
+            </a:r>
+            <a:endParaRPr lang="ru-RU"/>
+          </a:p>
+        </p:txBody>
+      </p:sp>
+      <p:sp>
+        <p:nvSpPr>
+          <p:cNvPr id="3" name="Content Placeholder 2">
+            <a:extLst>
+              <a:ext uri="{FF2B5EF4-FFF2-40B4-BE49-F238E27FC236}">
+                <a16:creationId xmlns:a16="http://schemas.microsoft.com/office/drawing/2014/main" id="{571BC3FA-836B-89CF-1AB9-5BDF051C66C6}"/>
               </a:ext>
             </a:extLst>
           </p:cNvPr>
@@ -2247,46 +2264,47 @@
           <a:p>
             <a:pPr lvl="0"/>
             <a:r>
-              <a:rPr lang="ru-RU"/>
-              <a:t>Образец текста</a:t>
+              <a:rPr lang="en-US"/>
+              <a:t>Click to edit Master text styles</a:t>
             </a:r>
           </a:p>
           <a:p>
             <a:pPr lvl="1"/>
             <a:r>
-              <a:rPr lang="ru-RU"/>
-              <a:t>Второй уровень</a:t>
+              <a:rPr lang="en-US"/>
+              <a:t>Second level</a:t>
             </a:r>
           </a:p>
           <a:p>
             <a:pPr lvl="2"/>
             <a:r>
-              <a:rPr lang="ru-RU"/>
-              <a:t>Третий уровень</a:t>
+              <a:rPr lang="en-US"/>
+              <a:t>Third level</a:t>
             </a:r>
           </a:p>
           <a:p>
             <a:pPr lvl="3"/>
             <a:r>
-              <a:rPr lang="ru-RU"/>
-              <a:t>Четвертый уровень</a:t>
+              <a:rPr lang="en-US"/>
+              <a:t>Fourth level</a:t>
             </a:r>
           </a:p>
           <a:p>
             <a:pPr lvl="4"/>
             <a:r>
-              <a:rPr lang="ru-RU"/>
-              <a:t>Пятый уровень</a:t>
-            </a:r>
-          </a:p>
-        </p:txBody>
-      </p:sp>
-      <p:sp>
-        <p:nvSpPr>
-          <p:cNvPr id="4" name="Текст 3">
-            <a:extLst>
-              <a:ext uri="{FF2B5EF4-FFF2-40B4-BE49-F238E27FC236}">
-                <a16:creationId xmlns:a16="http://schemas.microsoft.com/office/drawing/2014/main" id="{623BDE6B-F052-799E-4F4E-FB2633298980}"/>
+              <a:rPr lang="en-US"/>
+              <a:t>Fifth level</a:t>
+            </a:r>
+            <a:endParaRPr lang="ru-RU"/>
+          </a:p>
+        </p:txBody>
+      </p:sp>
+      <p:sp>
+        <p:nvSpPr>
+          <p:cNvPr id="4" name="Text Placeholder 3">
+            <a:extLst>
+              <a:ext uri="{FF2B5EF4-FFF2-40B4-BE49-F238E27FC236}">
+                <a16:creationId xmlns:a16="http://schemas.microsoft.com/office/drawing/2014/main" id="{DB48C85E-CE7B-7213-DD11-4AD279229F81}"/>
               </a:ext>
             </a:extLst>
           </p:cNvPr>
@@ -2346,18 +2364,18 @@
           <a:p>
             <a:pPr lvl="0"/>
             <a:r>
-              <a:rPr lang="ru-RU"/>
-              <a:t>Образец текста</a:t>
-            </a:r>
-          </a:p>
-        </p:txBody>
-      </p:sp>
-      <p:sp>
-        <p:nvSpPr>
-          <p:cNvPr id="5" name="Дата 4">
-            <a:extLst>
-              <a:ext uri="{FF2B5EF4-FFF2-40B4-BE49-F238E27FC236}">
-                <a16:creationId xmlns:a16="http://schemas.microsoft.com/office/drawing/2014/main" id="{0DAE8F71-2998-2109-06EE-465E2B4E5BF5}"/>
+              <a:rPr lang="en-US"/>
+              <a:t>Click to edit Master text styles</a:t>
+            </a:r>
+          </a:p>
+        </p:txBody>
+      </p:sp>
+      <p:sp>
+        <p:nvSpPr>
+          <p:cNvPr id="5" name="Date Placeholder 4">
+            <a:extLst>
+              <a:ext uri="{FF2B5EF4-FFF2-40B4-BE49-F238E27FC236}">
+                <a16:creationId xmlns:a16="http://schemas.microsoft.com/office/drawing/2014/main" id="{CF9693FD-555D-EED6-7521-C5E5C09E09ED}"/>
               </a:ext>
             </a:extLst>
           </p:cNvPr>
@@ -2373,9 +2391,9 @@
           <a:bodyPr/>
           <a:lstStyle/>
           <a:p>
-            <a:fld id="{9757B1A7-0FDC-40C9-B67F-A43EAC5AEB09}" type="datetimeFigureOut">
+            <a:fld id="{961A2009-0CEE-41C1-939A-B9C723B78133}" type="datetimeFigureOut">
               <a:rPr lang="ru-RU" smtClean="0"/>
-              <a:t>04.02.2026</a:t>
+              <a:t>05.03.2026</a:t>
             </a:fld>
             <a:endParaRPr lang="ru-RU"/>
           </a:p>
@@ -2383,10 +2401,10 @@
       </p:sp>
       <p:sp>
         <p:nvSpPr>
-          <p:cNvPr id="6" name="Нижний колонтитул 5">
-            <a:extLst>
-              <a:ext uri="{FF2B5EF4-FFF2-40B4-BE49-F238E27FC236}">
-                <a16:creationId xmlns:a16="http://schemas.microsoft.com/office/drawing/2014/main" id="{EE72EDA9-A6EA-E840-F542-5F2BBF1B9D4C}"/>
+          <p:cNvPr id="6" name="Footer Placeholder 5">
+            <a:extLst>
+              <a:ext uri="{FF2B5EF4-FFF2-40B4-BE49-F238E27FC236}">
+                <a16:creationId xmlns:a16="http://schemas.microsoft.com/office/drawing/2014/main" id="{217535D9-8FB8-5200-D756-907988077B80}"/>
               </a:ext>
             </a:extLst>
           </p:cNvPr>
@@ -2408,10 +2426,10 @@
       </p:sp>
       <p:sp>
         <p:nvSpPr>
-          <p:cNvPr id="7" name="Номер слайда 6">
-            <a:extLst>
-              <a:ext uri="{FF2B5EF4-FFF2-40B4-BE49-F238E27FC236}">
-                <a16:creationId xmlns:a16="http://schemas.microsoft.com/office/drawing/2014/main" id="{314370C1-CA3F-6E8B-01D0-CC3665606AF7}"/>
+          <p:cNvPr id="7" name="Slide Number Placeholder 6">
+            <a:extLst>
+              <a:ext uri="{FF2B5EF4-FFF2-40B4-BE49-F238E27FC236}">
+                <a16:creationId xmlns:a16="http://schemas.microsoft.com/office/drawing/2014/main" id="{38875E0F-D389-BB65-C7E7-B04BCA36DC9B}"/>
               </a:ext>
             </a:extLst>
           </p:cNvPr>
@@ -2427,7 +2445,7 @@
           <a:bodyPr/>
           <a:lstStyle/>
           <a:p>
-            <a:fld id="{42D7F972-A93D-42B4-85D0-25743E08EB40}" type="slidenum">
+            <a:fld id="{20CA96BB-6BF3-4E52-BE21-7A7A15C0727C}" type="slidenum">
               <a:rPr lang="ru-RU" smtClean="0"/>
               <a:t>‹#›</a:t>
             </a:fld>
@@ -2438,7 +2456,7 @@
     </p:spTree>
     <p:extLst>
       <p:ext uri="{BB962C8B-B14F-4D97-AF65-F5344CB8AC3E}">
-        <p14:creationId xmlns:p14="http://schemas.microsoft.com/office/powerpoint/2010/main" val="1135905457"/>
+        <p14:creationId xmlns:p14="http://schemas.microsoft.com/office/powerpoint/2010/main" val="2527503941"/>
       </p:ext>
     </p:extLst>
   </p:cSld>
@@ -2450,7 +2468,7 @@
 
 <file path=ppt/slideLayouts/slideLayout9.xml><?xml version="1.0" encoding="utf-8"?>
 <p:sldLayout xmlns:a="http://schemas.openxmlformats.org/drawingml/2006/main" xmlns:r="http://schemas.openxmlformats.org/officeDocument/2006/relationships" xmlns:p="http://schemas.openxmlformats.org/presentationml/2006/main" type="picTx" preserve="1">
-  <p:cSld name="Рисунок с подписью">
+  <p:cSld name="Picture with Caption">
     <p:spTree>
       <p:nvGrpSpPr>
         <p:cNvPr id="1" name=""/>
@@ -2467,10 +2485,10 @@
       </p:grpSpPr>
       <p:sp>
         <p:nvSpPr>
-          <p:cNvPr id="2" name="Заголовок 1">
-            <a:extLst>
-              <a:ext uri="{FF2B5EF4-FFF2-40B4-BE49-F238E27FC236}">
-                <a16:creationId xmlns:a16="http://schemas.microsoft.com/office/drawing/2014/main" id="{DD54BC52-FE78-BEE1-7B8E-8435C42CFF62}"/>
+          <p:cNvPr id="2" name="Title 1">
+            <a:extLst>
+              <a:ext uri="{FF2B5EF4-FFF2-40B4-BE49-F238E27FC236}">
+                <a16:creationId xmlns:a16="http://schemas.microsoft.com/office/drawing/2014/main" id="{0218E2C7-ED13-206D-9357-357009C8EA42}"/>
               </a:ext>
             </a:extLst>
           </p:cNvPr>
@@ -2496,18 +2514,19 @@
           </a:lstStyle>
           <a:p>
             <a:r>
-              <a:rPr lang="ru-RU"/>
-              <a:t>Образец заголовка</a:t>
-            </a:r>
-          </a:p>
-        </p:txBody>
-      </p:sp>
-      <p:sp>
-        <p:nvSpPr>
-          <p:cNvPr id="3" name="Рисунок 2">
-            <a:extLst>
-              <a:ext uri="{FF2B5EF4-FFF2-40B4-BE49-F238E27FC236}">
-                <a16:creationId xmlns:a16="http://schemas.microsoft.com/office/drawing/2014/main" id="{1BD269C9-E65F-7FCD-66A5-E5E386896106}"/>
+              <a:rPr lang="en-US"/>
+              <a:t>Click to edit Master title style</a:t>
+            </a:r>
+            <a:endParaRPr lang="ru-RU"/>
+          </a:p>
+        </p:txBody>
+      </p:sp>
+      <p:sp>
+        <p:nvSpPr>
+          <p:cNvPr id="3" name="Picture Placeholder 2">
+            <a:extLst>
+              <a:ext uri="{FF2B5EF4-FFF2-40B4-BE49-F238E27FC236}">
+                <a16:creationId xmlns:a16="http://schemas.microsoft.com/office/drawing/2014/main" id="{CF0BC659-B165-5621-45DF-BAE304B61952}"/>
               </a:ext>
             </a:extLst>
           </p:cNvPr>
@@ -2571,10 +2590,10 @@
       </p:sp>
       <p:sp>
         <p:nvSpPr>
-          <p:cNvPr id="4" name="Текст 3">
-            <a:extLst>
-              <a:ext uri="{FF2B5EF4-FFF2-40B4-BE49-F238E27FC236}">
-                <a16:creationId xmlns:a16="http://schemas.microsoft.com/office/drawing/2014/main" id="{86880BC9-5579-B95C-D785-5C58CC3A4A0F}"/>
+          <p:cNvPr id="4" name="Text Placeholder 3">
+            <a:extLst>
+              <a:ext uri="{FF2B5EF4-FFF2-40B4-BE49-F238E27FC236}">
+                <a16:creationId xmlns:a16="http://schemas.microsoft.com/office/drawing/2014/main" id="{5F0B0D94-F135-2B1F-1FC9-84ED17DEB08C}"/>
               </a:ext>
             </a:extLst>
           </p:cNvPr>
@@ -2634,18 +2653,18 @@
           <a:p>
             <a:pPr lvl="0"/>
             <a:r>
-              <a:rPr lang="ru-RU"/>
-              <a:t>Образец текста</a:t>
-            </a:r>
-          </a:p>
-        </p:txBody>
-      </p:sp>
-      <p:sp>
-        <p:nvSpPr>
-          <p:cNvPr id="5" name="Дата 4">
-            <a:extLst>
-              <a:ext uri="{FF2B5EF4-FFF2-40B4-BE49-F238E27FC236}">
-                <a16:creationId xmlns:a16="http://schemas.microsoft.com/office/drawing/2014/main" id="{2736DD76-FEAD-D603-6FB6-2CC6B872DAC5}"/>
+              <a:rPr lang="en-US"/>
+              <a:t>Click to edit Master text styles</a:t>
+            </a:r>
+          </a:p>
+        </p:txBody>
+      </p:sp>
+      <p:sp>
+        <p:nvSpPr>
+          <p:cNvPr id="5" name="Date Placeholder 4">
+            <a:extLst>
+              <a:ext uri="{FF2B5EF4-FFF2-40B4-BE49-F238E27FC236}">
+                <a16:creationId xmlns:a16="http://schemas.microsoft.com/office/drawing/2014/main" id="{7F6DC1A2-030A-FE0C-0C00-5E8BE8A225D8}"/>
               </a:ext>
             </a:extLst>
           </p:cNvPr>
@@ -2661,9 +2680,9 @@
           <a:bodyPr/>
           <a:lstStyle/>
           <a:p>
-            <a:fld id="{9757B1A7-0FDC-40C9-B67F-A43EAC5AEB09}" type="datetimeFigureOut">
+            <a:fld id="{961A2009-0CEE-41C1-939A-B9C723B78133}" type="datetimeFigureOut">
               <a:rPr lang="ru-RU" smtClean="0"/>
-              <a:t>04.02.2026</a:t>
+              <a:t>05.03.2026</a:t>
             </a:fld>
             <a:endParaRPr lang="ru-RU"/>
           </a:p>
@@ -2671,10 +2690,10 @@
       </p:sp>
       <p:sp>
         <p:nvSpPr>
-          <p:cNvPr id="6" name="Нижний колонтитул 5">
-            <a:extLst>
-              <a:ext uri="{FF2B5EF4-FFF2-40B4-BE49-F238E27FC236}">
-                <a16:creationId xmlns:a16="http://schemas.microsoft.com/office/drawing/2014/main" id="{F010FA7A-0A14-3814-BFA9-88C08D20F106}"/>
+          <p:cNvPr id="6" name="Footer Placeholder 5">
+            <a:extLst>
+              <a:ext uri="{FF2B5EF4-FFF2-40B4-BE49-F238E27FC236}">
+                <a16:creationId xmlns:a16="http://schemas.microsoft.com/office/drawing/2014/main" id="{82FD8063-CB8E-3AE3-4234-1A7D37DD9201}"/>
               </a:ext>
             </a:extLst>
           </p:cNvPr>
@@ -2696,10 +2715,10 @@
       </p:sp>
       <p:sp>
         <p:nvSpPr>
-          <p:cNvPr id="7" name="Номер слайда 6">
-            <a:extLst>
-              <a:ext uri="{FF2B5EF4-FFF2-40B4-BE49-F238E27FC236}">
-                <a16:creationId xmlns:a16="http://schemas.microsoft.com/office/drawing/2014/main" id="{40E478F9-C8B7-6D46-AAAA-482FDE086C30}"/>
+          <p:cNvPr id="7" name="Slide Number Placeholder 6">
+            <a:extLst>
+              <a:ext uri="{FF2B5EF4-FFF2-40B4-BE49-F238E27FC236}">
+                <a16:creationId xmlns:a16="http://schemas.microsoft.com/office/drawing/2014/main" id="{866BA33C-BB80-BF46-F329-7D49E95D05B5}"/>
               </a:ext>
             </a:extLst>
           </p:cNvPr>
@@ -2715,7 +2734,7 @@
           <a:bodyPr/>
           <a:lstStyle/>
           <a:p>
-            <a:fld id="{42D7F972-A93D-42B4-85D0-25743E08EB40}" type="slidenum">
+            <a:fld id="{20CA96BB-6BF3-4E52-BE21-7A7A15C0727C}" type="slidenum">
               <a:rPr lang="ru-RU" smtClean="0"/>
               <a:t>‹#›</a:t>
             </a:fld>
@@ -2726,7 +2745,7 @@
     </p:spTree>
     <p:extLst>
       <p:ext uri="{BB962C8B-B14F-4D97-AF65-F5344CB8AC3E}">
-        <p14:creationId xmlns:p14="http://schemas.microsoft.com/office/powerpoint/2010/main" val="1468998930"/>
+        <p14:creationId xmlns:p14="http://schemas.microsoft.com/office/powerpoint/2010/main" val="1941709509"/>
       </p:ext>
     </p:extLst>
   </p:cSld>
@@ -2760,10 +2779,10 @@
       </p:grpSpPr>
       <p:sp>
         <p:nvSpPr>
-          <p:cNvPr id="2" name="Заголовок 1">
-            <a:extLst>
-              <a:ext uri="{FF2B5EF4-FFF2-40B4-BE49-F238E27FC236}">
-                <a16:creationId xmlns:a16="http://schemas.microsoft.com/office/drawing/2014/main" id="{749D9B31-6718-4D0C-A840-3A4A4C94FA6B}"/>
+          <p:cNvPr id="2" name="Title Placeholder 1">
+            <a:extLst>
+              <a:ext uri="{FF2B5EF4-FFF2-40B4-BE49-F238E27FC236}">
+                <a16:creationId xmlns:a16="http://schemas.microsoft.com/office/drawing/2014/main" id="{06FBB2AE-525E-7CCA-93BA-D8C9D71A6E8B}"/>
               </a:ext>
             </a:extLst>
           </p:cNvPr>
@@ -2790,18 +2809,19 @@
           <a:lstStyle/>
           <a:p>
             <a:r>
-              <a:rPr lang="ru-RU"/>
-              <a:t>Образец заголовка</a:t>
-            </a:r>
-          </a:p>
-        </p:txBody>
-      </p:sp>
-      <p:sp>
-        <p:nvSpPr>
-          <p:cNvPr id="3" name="Текст 2">
-            <a:extLst>
-              <a:ext uri="{FF2B5EF4-FFF2-40B4-BE49-F238E27FC236}">
-                <a16:creationId xmlns:a16="http://schemas.microsoft.com/office/drawing/2014/main" id="{B1D7B4FD-0B6C-881B-A500-1BCF6223C85D}"/>
+              <a:rPr lang="en-US"/>
+              <a:t>Click to edit Master title style</a:t>
+            </a:r>
+            <a:endParaRPr lang="ru-RU"/>
+          </a:p>
+        </p:txBody>
+      </p:sp>
+      <p:sp>
+        <p:nvSpPr>
+          <p:cNvPr id="3" name="Text Placeholder 2">
+            <a:extLst>
+              <a:ext uri="{FF2B5EF4-FFF2-40B4-BE49-F238E27FC236}">
+                <a16:creationId xmlns:a16="http://schemas.microsoft.com/office/drawing/2014/main" id="{67DFA169-C654-D5F6-6588-5CD8790373F5}"/>
               </a:ext>
             </a:extLst>
           </p:cNvPr>
@@ -2829,46 +2849,47 @@
           <a:p>
             <a:pPr lvl="0"/>
             <a:r>
-              <a:rPr lang="ru-RU"/>
-              <a:t>Образец текста</a:t>
+              <a:rPr lang="en-US"/>
+              <a:t>Click to edit Master text styles</a:t>
             </a:r>
           </a:p>
           <a:p>
             <a:pPr lvl="1"/>
             <a:r>
-              <a:rPr lang="ru-RU"/>
-              <a:t>Второй уровень</a:t>
+              <a:rPr lang="en-US"/>
+              <a:t>Second level</a:t>
             </a:r>
           </a:p>
           <a:p>
             <a:pPr lvl="2"/>
             <a:r>
-              <a:rPr lang="ru-RU"/>
-              <a:t>Третий уровень</a:t>
+              <a:rPr lang="en-US"/>
+              <a:t>Third level</a:t>
             </a:r>
           </a:p>
           <a:p>
             <a:pPr lvl="3"/>
             <a:r>
-              <a:rPr lang="ru-RU"/>
-              <a:t>Четвертый уровень</a:t>
+              <a:rPr lang="en-US"/>
+              <a:t>Fourth level</a:t>
             </a:r>
           </a:p>
           <a:p>
             <a:pPr lvl="4"/>
             <a:r>
-              <a:rPr lang="ru-RU"/>
-              <a:t>Пятый уровень</a:t>
-            </a:r>
-          </a:p>
-        </p:txBody>
-      </p:sp>
-      <p:sp>
-        <p:nvSpPr>
-          <p:cNvPr id="4" name="Дата 3">
-            <a:extLst>
-              <a:ext uri="{FF2B5EF4-FFF2-40B4-BE49-F238E27FC236}">
-                <a16:creationId xmlns:a16="http://schemas.microsoft.com/office/drawing/2014/main" id="{45002596-66F9-503B-31AA-E09879AF502D}"/>
+              <a:rPr lang="en-US"/>
+              <a:t>Fifth level</a:t>
+            </a:r>
+            <a:endParaRPr lang="ru-RU"/>
+          </a:p>
+        </p:txBody>
+      </p:sp>
+      <p:sp>
+        <p:nvSpPr>
+          <p:cNvPr id="4" name="Date Placeholder 3">
+            <a:extLst>
+              <a:ext uri="{FF2B5EF4-FFF2-40B4-BE49-F238E27FC236}">
+                <a16:creationId xmlns:a16="http://schemas.microsoft.com/office/drawing/2014/main" id="{2D865572-007F-BCB6-C95A-0F9EA0E8BEA6}"/>
               </a:ext>
             </a:extLst>
           </p:cNvPr>
@@ -2895,16 +2916,16 @@
               <a:defRPr sz="1200">
                 <a:solidFill>
                   <a:schemeClr val="tx1">
-                    <a:tint val="75000"/>
+                    <a:tint val="82000"/>
                   </a:schemeClr>
                 </a:solidFill>
               </a:defRPr>
             </a:lvl1pPr>
           </a:lstStyle>
           <a:p>
-            <a:fld id="{9757B1A7-0FDC-40C9-B67F-A43EAC5AEB09}" type="datetimeFigureOut">
+            <a:fld id="{961A2009-0CEE-41C1-939A-B9C723B78133}" type="datetimeFigureOut">
               <a:rPr lang="ru-RU" smtClean="0"/>
-              <a:t>04.02.2026</a:t>
+              <a:t>05.03.2026</a:t>
             </a:fld>
             <a:endParaRPr lang="ru-RU"/>
           </a:p>
@@ -2912,10 +2933,10 @@
       </p:sp>
       <p:sp>
         <p:nvSpPr>
-          <p:cNvPr id="5" name="Нижний колонтитул 4">
-            <a:extLst>
-              <a:ext uri="{FF2B5EF4-FFF2-40B4-BE49-F238E27FC236}">
-                <a16:creationId xmlns:a16="http://schemas.microsoft.com/office/drawing/2014/main" id="{1A7E95C6-2D43-6725-4E98-7A7F46451A77}"/>
+          <p:cNvPr id="5" name="Footer Placeholder 4">
+            <a:extLst>
+              <a:ext uri="{FF2B5EF4-FFF2-40B4-BE49-F238E27FC236}">
+                <a16:creationId xmlns:a16="http://schemas.microsoft.com/office/drawing/2014/main" id="{C3C2D9C5-0B41-1C6E-3AE9-7EAFABB1D0CE}"/>
               </a:ext>
             </a:extLst>
           </p:cNvPr>
@@ -2942,7 +2963,7 @@
               <a:defRPr sz="1200">
                 <a:solidFill>
                   <a:schemeClr val="tx1">
-                    <a:tint val="75000"/>
+                    <a:tint val="82000"/>
                   </a:schemeClr>
                 </a:solidFill>
               </a:defRPr>
@@ -2955,10 +2976,10 @@
       </p:sp>
       <p:sp>
         <p:nvSpPr>
-          <p:cNvPr id="6" name="Номер слайда 5">
-            <a:extLst>
-              <a:ext uri="{FF2B5EF4-FFF2-40B4-BE49-F238E27FC236}">
-                <a16:creationId xmlns:a16="http://schemas.microsoft.com/office/drawing/2014/main" id="{31D286F6-6E8E-C632-9EC1-86635101D1FE}"/>
+          <p:cNvPr id="6" name="Slide Number Placeholder 5">
+            <a:extLst>
+              <a:ext uri="{FF2B5EF4-FFF2-40B4-BE49-F238E27FC236}">
+                <a16:creationId xmlns:a16="http://schemas.microsoft.com/office/drawing/2014/main" id="{C3CF974B-20B7-4F1A-F8DB-7F358E5133FF}"/>
               </a:ext>
             </a:extLst>
           </p:cNvPr>
@@ -2985,14 +3006,14 @@
               <a:defRPr sz="1200">
                 <a:solidFill>
                   <a:schemeClr val="tx1">
-                    <a:tint val="75000"/>
+                    <a:tint val="82000"/>
                   </a:schemeClr>
                 </a:solidFill>
               </a:defRPr>
             </a:lvl1pPr>
           </a:lstStyle>
           <a:p>
-            <a:fld id="{42D7F972-A93D-42B4-85D0-25743E08EB40}" type="slidenum">
+            <a:fld id="{20CA96BB-6BF3-4E52-BE21-7A7A15C0727C}" type="slidenum">
               <a:rPr lang="ru-RU" smtClean="0"/>
               <a:t>‹#›</a:t>
             </a:fld>
@@ -3003,7 +3024,7 @@
     </p:spTree>
     <p:extLst>
       <p:ext uri="{BB962C8B-B14F-4D97-AF65-F5344CB8AC3E}">
-        <p14:creationId xmlns:p14="http://schemas.microsoft.com/office/powerpoint/2010/main" val="980976171"/>
+        <p14:creationId xmlns:p14="http://schemas.microsoft.com/office/powerpoint/2010/main" val="223362461"/>
       </p:ext>
     </p:extLst>
   </p:cSld>
@@ -3323,10 +3344,10 @@
       </p:grpSpPr>
       <p:sp>
         <p:nvSpPr>
-          <p:cNvPr id="2" name="Заголовок 1">
-            <a:extLst>
-              <a:ext uri="{FF2B5EF4-FFF2-40B4-BE49-F238E27FC236}">
-                <a16:creationId xmlns:a16="http://schemas.microsoft.com/office/drawing/2014/main" id="{356D6F75-25DD-E288-5FF1-36D6AA9A2826}"/>
+          <p:cNvPr id="2" name="Title 1">
+            <a:extLst>
+              <a:ext uri="{FF2B5EF4-FFF2-40B4-BE49-F238E27FC236}">
+                <a16:creationId xmlns:a16="http://schemas.microsoft.com/office/drawing/2014/main" id="{8CADC51B-0416-BB8E-AEB5-3D1BBB64ACED}"/>
               </a:ext>
             </a:extLst>
           </p:cNvPr>
@@ -3342,16 +3363,16 @@
           <a:bodyPr/>
           <a:lstStyle/>
           <a:p>
-            <a:endParaRPr lang="ru-RU" dirty="0"/>
-          </a:p>
-        </p:txBody>
-      </p:sp>
-      <p:sp>
-        <p:nvSpPr>
-          <p:cNvPr id="3" name="Подзаголовок 2">
-            <a:extLst>
-              <a:ext uri="{FF2B5EF4-FFF2-40B4-BE49-F238E27FC236}">
-                <a16:creationId xmlns:a16="http://schemas.microsoft.com/office/drawing/2014/main" id="{45152EA4-116E-D6E2-4795-AAD70D803A8E}"/>
+            <a:endParaRPr lang="ru-RU"/>
+          </a:p>
+        </p:txBody>
+      </p:sp>
+      <p:sp>
+        <p:nvSpPr>
+          <p:cNvPr id="3" name="Subtitle 2">
+            <a:extLst>
+              <a:ext uri="{FF2B5EF4-FFF2-40B4-BE49-F238E27FC236}">
+                <a16:creationId xmlns:a16="http://schemas.microsoft.com/office/drawing/2014/main" id="{FB50E8CD-A314-35A4-F259-7EA4041DB80B}"/>
               </a:ext>
             </a:extLst>
           </p:cNvPr>
@@ -3374,7 +3395,7 @@
     </p:spTree>
     <p:extLst>
       <p:ext uri="{BB962C8B-B14F-4D97-AF65-F5344CB8AC3E}">
-        <p14:creationId xmlns:p14="http://schemas.microsoft.com/office/powerpoint/2010/main" val="3660602045"/>
+        <p14:creationId xmlns:p14="http://schemas.microsoft.com/office/powerpoint/2010/main" val="2517044419"/>
       </p:ext>
     </p:extLst>
   </p:cSld>
@@ -3385,9 +3406,9 @@
 </file>
 
 <file path=ppt/theme/theme1.xml><?xml version="1.0" encoding="utf-8"?>
-<a:theme xmlns:a="http://schemas.openxmlformats.org/drawingml/2006/main" name="Тема Office">
+<a:theme xmlns:a="http://schemas.openxmlformats.org/drawingml/2006/main" name="Office Theme">
   <a:themeElements>
-    <a:clrScheme name="Стандартная">
+    <a:clrScheme name="Office">
       <a:dk1>
         <a:sysClr val="windowText" lastClr="000000"/>
       </a:dk1>
@@ -3395,39 +3416,39 @@
         <a:sysClr val="window" lastClr="FFFFFF"/>
       </a:lt1>
       <a:dk2>
-        <a:srgbClr val="44546A"/>
+        <a:srgbClr val="0E2841"/>
       </a:dk2>
       <a:lt2>
-        <a:srgbClr val="E7E6E6"/>
+        <a:srgbClr val="E8E8E8"/>
       </a:lt2>
       <a:accent1>
-        <a:srgbClr val="4472C4"/>
+        <a:srgbClr val="156082"/>
       </a:accent1>
       <a:accent2>
-        <a:srgbClr val="ED7D31"/>
+        <a:srgbClr val="E97132"/>
       </a:accent2>
       <a:accent3>
-        <a:srgbClr val="A5A5A5"/>
+        <a:srgbClr val="196B24"/>
       </a:accent3>
       <a:accent4>
-        <a:srgbClr val="FFC000"/>
+        <a:srgbClr val="0F9ED5"/>
       </a:accent4>
       <a:accent5>
-        <a:srgbClr val="5B9BD5"/>
+        <a:srgbClr val="A02B93"/>
       </a:accent5>
       <a:accent6>
-        <a:srgbClr val="70AD47"/>
+        <a:srgbClr val="4EA72E"/>
       </a:accent6>
       <a:hlink>
-        <a:srgbClr val="0563C1"/>
+        <a:srgbClr val="467886"/>
       </a:hlink>
       <a:folHlink>
-        <a:srgbClr val="954F72"/>
+        <a:srgbClr val="96607D"/>
       </a:folHlink>
     </a:clrScheme>
-    <a:fontScheme name="Стандартная">
+    <a:fontScheme name="Office">
       <a:majorFont>
-        <a:latin typeface="Calibri Light" panose="020F0302020204030204"/>
+        <a:latin typeface="Aptos Display" panose="02110004020202020204"/>
         <a:ea typeface=""/>
         <a:cs typeface=""/>
         <a:font script="Jpan" typeface="游ゴシック Light"/>
@@ -3479,7 +3500,7 @@
         <a:font script="Tfng" typeface="Ebrima"/>
       </a:majorFont>
       <a:minorFont>
-        <a:latin typeface="Calibri" panose="020F0502020204030204"/>
+        <a:latin typeface="Aptos" panose="02110004020202020204"/>
         <a:ea typeface=""/>
         <a:cs typeface=""/>
         <a:font script="Jpan" typeface="游ゴシック"/>
@@ -3531,7 +3552,7 @@
         <a:font script="Tfng" typeface="Ebrima"/>
       </a:minorFont>
     </a:fontScheme>
-    <a:fmtScheme name="Стандартная">
+    <a:fmtScheme name="Office">
       <a:fillStyleLst>
         <a:solidFill>
           <a:schemeClr val="phClr"/>
@@ -3590,13 +3611,6 @@
         </a:gradFill>
       </a:fillStyleLst>
       <a:lnStyleLst>
-        <a:ln w="6350" cap="flat" cmpd="sng" algn="ctr">
-          <a:solidFill>
-            <a:schemeClr val="phClr"/>
-          </a:solidFill>
-          <a:prstDash val="solid"/>
-          <a:miter lim="800000"/>
-        </a:ln>
         <a:ln w="12700" cap="flat" cmpd="sng" algn="ctr">
           <a:solidFill>
             <a:schemeClr val="phClr"/>
@@ -3605,6 +3619,13 @@
           <a:miter lim="800000"/>
         </a:ln>
         <a:ln w="19050" cap="flat" cmpd="sng" algn="ctr">
+          <a:solidFill>
+            <a:schemeClr val="phClr"/>
+          </a:solidFill>
+          <a:prstDash val="solid"/>
+          <a:miter lim="800000"/>
+        </a:ln>
+        <a:ln w="25400" cap="flat" cmpd="sng" algn="ctr">
           <a:solidFill>
             <a:schemeClr val="phClr"/>
           </a:solidFill>
@@ -3669,11 +3690,31 @@
       </a:bgFillStyleLst>
     </a:fmtScheme>
   </a:themeElements>
-  <a:objectDefaults/>
+  <a:objectDefaults>
+    <a:lnDef>
+      <a:spPr/>
+      <a:bodyPr/>
+      <a:lstStyle/>
+      <a:style>
+        <a:lnRef idx="2">
+          <a:schemeClr val="accent1"/>
+        </a:lnRef>
+        <a:fillRef idx="0">
+          <a:schemeClr val="accent1"/>
+        </a:fillRef>
+        <a:effectRef idx="1">
+          <a:schemeClr val="accent1"/>
+        </a:effectRef>
+        <a:fontRef idx="minor">
+          <a:schemeClr val="tx1"/>
+        </a:fontRef>
+      </a:style>
+    </a:lnDef>
+  </a:objectDefaults>
   <a:extraClrSchemeLst/>
   <a:extLst>
     <a:ext uri="{05A4C25C-085E-4340-85A3-A5531E510DB2}">
-      <thm15:themeFamily xmlns:thm15="http://schemas.microsoft.com/office/thememl/2012/main" name="Office Theme" id="{62F939B6-93AF-4DB8-9C6B-D6C7DFDC589F}" vid="{4A3C46E8-61CC-4603-A589-7422A47A8E4A}"/>
+      <thm15:themeFamily xmlns:thm15="http://schemas.microsoft.com/office/thememl/2012/main" name="Office Theme" id="{2E142A2C-CD16-42D6-873A-C26D2A0506FA}" vid="{1BDDFF52-6CD6-40A5-AB3C-68EB2F1E4D0A}"/>
     </a:ext>
   </a:extLst>
 </a:theme>

</xml_diff>

<commit_message>
Regenerate docProps/app.xml on save, and clean the bundled template
The extended properties part was copied from the bundled template and never
recomputed, so every deck reported <Slides>1</Slides>, <Paragraphs>0</Paragraphs>
and the template's own slide title, whatever it actually contained. The
counts and the slide titles are now read back out of the package after the
parts have been written, so the summary describes the file being saved. The
Fonts Used and Theme sections are left as they were parsed.

The template also carried lang="ru-RU" on 84 runs across presentation.xml,
the master and all eleven layouts, so text in every produced file was marked
as edited in a language the user never chose; those are now en-US, matching
the 62 runs that already were.

Finally it shipped docProps/thumbnail.jpeg — a preview of the template, sent
out as the preview of the user's document. The part, its package
relationship and the now-unused jpeg content-type default are removed.
</commit_message>
<xml_diff>
--- a/aspose/slides_foss/_internal/pptx/Template.pptx
+++ b/aspose/slides_foss/_internal/pptx/Template.pptx
@@ -11,7 +11,7 @@
   <p:notesSz cx="6858000" cy="9144000"/>
   <p:defaultTextStyle>
     <a:defPPr>
-      <a:defRPr lang="ru-RU"/>
+      <a:defRPr lang="en-US"/>
     </a:defPPr>
     <a:lvl1pPr marL="0" algn="l" defTabSz="914400" rtl="0" eaLnBrk="1" latinLnBrk="0" hangingPunct="1">
       <a:defRPr sz="1800" kern="1200">
@@ -158,7 +158,7 @@
               <a:rPr lang="en-US"/>
               <a:t>Click to edit Master title style</a:t>
             </a:r>
-            <a:endParaRPr lang="ru-RU"/>
+            <a:endParaRPr lang="en-US"/>
           </a:p>
         </p:txBody>
       </p:sp>
@@ -229,7 +229,7 @@
               <a:rPr lang="en-US"/>
               <a:t>Click to edit Master subtitle style</a:t>
             </a:r>
-            <a:endParaRPr lang="ru-RU"/>
+            <a:endParaRPr lang="en-US"/>
           </a:p>
         </p:txBody>
       </p:sp>
@@ -255,10 +255,10 @@
           <a:lstStyle/>
           <a:p>
             <a:fld id="{961A2009-0CEE-41C1-939A-B9C723B78133}" type="datetimeFigureOut">
-              <a:rPr lang="ru-RU" smtClean="0"/>
+              <a:rPr lang="en-US" smtClean="0"/>
               <a:t>05.03.2026</a:t>
             </a:fld>
-            <a:endParaRPr lang="ru-RU"/>
+            <a:endParaRPr lang="en-US"/>
           </a:p>
         </p:txBody>
       </p:sp>
@@ -283,7 +283,7 @@
           <a:bodyPr/>
           <a:lstStyle/>
           <a:p>
-            <a:endParaRPr lang="ru-RU"/>
+            <a:endParaRPr lang="en-US"/>
           </a:p>
         </p:txBody>
       </p:sp>
@@ -309,10 +309,10 @@
           <a:lstStyle/>
           <a:p>
             <a:fld id="{20CA96BB-6BF3-4E52-BE21-7A7A15C0727C}" type="slidenum">
-              <a:rPr lang="ru-RU" smtClean="0"/>
+              <a:rPr lang="en-US" smtClean="0"/>
               <a:t>‹#›</a:t>
             </a:fld>
-            <a:endParaRPr lang="ru-RU"/>
+            <a:endParaRPr lang="en-US"/>
           </a:p>
         </p:txBody>
       </p:sp>
@@ -371,7 +371,7 @@
               <a:rPr lang="en-US"/>
               <a:t>Click to edit Master title style</a:t>
             </a:r>
-            <a:endParaRPr lang="ru-RU"/>
+            <a:endParaRPr lang="en-US"/>
           </a:p>
         </p:txBody>
       </p:sp>
@@ -429,7 +429,7 @@
               <a:rPr lang="en-US"/>
               <a:t>Fifth level</a:t>
             </a:r>
-            <a:endParaRPr lang="ru-RU"/>
+            <a:endParaRPr lang="en-US"/>
           </a:p>
         </p:txBody>
       </p:sp>
@@ -455,10 +455,10 @@
           <a:lstStyle/>
           <a:p>
             <a:fld id="{961A2009-0CEE-41C1-939A-B9C723B78133}" type="datetimeFigureOut">
-              <a:rPr lang="ru-RU" smtClean="0"/>
+              <a:rPr lang="en-US" smtClean="0"/>
               <a:t>05.03.2026</a:t>
             </a:fld>
-            <a:endParaRPr lang="ru-RU"/>
+            <a:endParaRPr lang="en-US"/>
           </a:p>
         </p:txBody>
       </p:sp>
@@ -483,7 +483,7 @@
           <a:bodyPr/>
           <a:lstStyle/>
           <a:p>
-            <a:endParaRPr lang="ru-RU"/>
+            <a:endParaRPr lang="en-US"/>
           </a:p>
         </p:txBody>
       </p:sp>
@@ -509,10 +509,10 @@
           <a:lstStyle/>
           <a:p>
             <a:fld id="{20CA96BB-6BF3-4E52-BE21-7A7A15C0727C}" type="slidenum">
-              <a:rPr lang="ru-RU" smtClean="0"/>
+              <a:rPr lang="en-US" smtClean="0"/>
               <a:t>‹#›</a:t>
             </a:fld>
-            <a:endParaRPr lang="ru-RU"/>
+            <a:endParaRPr lang="en-US"/>
           </a:p>
         </p:txBody>
       </p:sp>
@@ -576,7 +576,7 @@
               <a:rPr lang="en-US"/>
               <a:t>Click to edit Master title style</a:t>
             </a:r>
-            <a:endParaRPr lang="ru-RU"/>
+            <a:endParaRPr lang="en-US"/>
           </a:p>
         </p:txBody>
       </p:sp>
@@ -639,7 +639,7 @@
               <a:rPr lang="en-US"/>
               <a:t>Fifth level</a:t>
             </a:r>
-            <a:endParaRPr lang="ru-RU"/>
+            <a:endParaRPr lang="en-US"/>
           </a:p>
         </p:txBody>
       </p:sp>
@@ -665,10 +665,10 @@
           <a:lstStyle/>
           <a:p>
             <a:fld id="{961A2009-0CEE-41C1-939A-B9C723B78133}" type="datetimeFigureOut">
-              <a:rPr lang="ru-RU" smtClean="0"/>
+              <a:rPr lang="en-US" smtClean="0"/>
               <a:t>05.03.2026</a:t>
             </a:fld>
-            <a:endParaRPr lang="ru-RU"/>
+            <a:endParaRPr lang="en-US"/>
           </a:p>
         </p:txBody>
       </p:sp>
@@ -693,7 +693,7 @@
           <a:bodyPr/>
           <a:lstStyle/>
           <a:p>
-            <a:endParaRPr lang="ru-RU"/>
+            <a:endParaRPr lang="en-US"/>
           </a:p>
         </p:txBody>
       </p:sp>
@@ -719,10 +719,10 @@
           <a:lstStyle/>
           <a:p>
             <a:fld id="{20CA96BB-6BF3-4E52-BE21-7A7A15C0727C}" type="slidenum">
-              <a:rPr lang="ru-RU" smtClean="0"/>
+              <a:rPr lang="en-US" smtClean="0"/>
               <a:t>‹#›</a:t>
             </a:fld>
-            <a:endParaRPr lang="ru-RU"/>
+            <a:endParaRPr lang="en-US"/>
           </a:p>
         </p:txBody>
       </p:sp>
@@ -781,7 +781,7 @@
               <a:rPr lang="en-US"/>
               <a:t>Click to edit Master title style</a:t>
             </a:r>
-            <a:endParaRPr lang="ru-RU"/>
+            <a:endParaRPr lang="en-US"/>
           </a:p>
         </p:txBody>
       </p:sp>
@@ -839,7 +839,7 @@
               <a:rPr lang="en-US"/>
               <a:t>Fifth level</a:t>
             </a:r>
-            <a:endParaRPr lang="ru-RU"/>
+            <a:endParaRPr lang="en-US"/>
           </a:p>
         </p:txBody>
       </p:sp>
@@ -865,10 +865,10 @@
           <a:lstStyle/>
           <a:p>
             <a:fld id="{961A2009-0CEE-41C1-939A-B9C723B78133}" type="datetimeFigureOut">
-              <a:rPr lang="ru-RU" smtClean="0"/>
+              <a:rPr lang="en-US" smtClean="0"/>
               <a:t>05.03.2026</a:t>
             </a:fld>
-            <a:endParaRPr lang="ru-RU"/>
+            <a:endParaRPr lang="en-US"/>
           </a:p>
         </p:txBody>
       </p:sp>
@@ -893,7 +893,7 @@
           <a:bodyPr/>
           <a:lstStyle/>
           <a:p>
-            <a:endParaRPr lang="ru-RU"/>
+            <a:endParaRPr lang="en-US"/>
           </a:p>
         </p:txBody>
       </p:sp>
@@ -919,10 +919,10 @@
           <a:lstStyle/>
           <a:p>
             <a:fld id="{20CA96BB-6BF3-4E52-BE21-7A7A15C0727C}" type="slidenum">
-              <a:rPr lang="ru-RU" smtClean="0"/>
+              <a:rPr lang="en-US" smtClean="0"/>
               <a:t>‹#›</a:t>
             </a:fld>
-            <a:endParaRPr lang="ru-RU"/>
+            <a:endParaRPr lang="en-US"/>
           </a:p>
         </p:txBody>
       </p:sp>
@@ -990,7 +990,7 @@
               <a:rPr lang="en-US"/>
               <a:t>Click to edit Master title style</a:t>
             </a:r>
-            <a:endParaRPr lang="ru-RU"/>
+            <a:endParaRPr lang="en-US"/>
           </a:p>
         </p:txBody>
       </p:sp>
@@ -1141,10 +1141,10 @@
           <a:lstStyle/>
           <a:p>
             <a:fld id="{961A2009-0CEE-41C1-939A-B9C723B78133}" type="datetimeFigureOut">
-              <a:rPr lang="ru-RU" smtClean="0"/>
+              <a:rPr lang="en-US" smtClean="0"/>
               <a:t>05.03.2026</a:t>
             </a:fld>
-            <a:endParaRPr lang="ru-RU"/>
+            <a:endParaRPr lang="en-US"/>
           </a:p>
         </p:txBody>
       </p:sp>
@@ -1169,7 +1169,7 @@
           <a:bodyPr/>
           <a:lstStyle/>
           <a:p>
-            <a:endParaRPr lang="ru-RU"/>
+            <a:endParaRPr lang="en-US"/>
           </a:p>
         </p:txBody>
       </p:sp>
@@ -1195,10 +1195,10 @@
           <a:lstStyle/>
           <a:p>
             <a:fld id="{20CA96BB-6BF3-4E52-BE21-7A7A15C0727C}" type="slidenum">
-              <a:rPr lang="ru-RU" smtClean="0"/>
+              <a:rPr lang="en-US" smtClean="0"/>
               <a:t>‹#›</a:t>
             </a:fld>
-            <a:endParaRPr lang="ru-RU"/>
+            <a:endParaRPr lang="en-US"/>
           </a:p>
         </p:txBody>
       </p:sp>
@@ -1257,7 +1257,7 @@
               <a:rPr lang="en-US"/>
               <a:t>Click to edit Master title style</a:t>
             </a:r>
-            <a:endParaRPr lang="ru-RU"/>
+            <a:endParaRPr lang="en-US"/>
           </a:p>
         </p:txBody>
       </p:sp>
@@ -1320,7 +1320,7 @@
               <a:rPr lang="en-US"/>
               <a:t>Fifth level</a:t>
             </a:r>
-            <a:endParaRPr lang="ru-RU"/>
+            <a:endParaRPr lang="en-US"/>
           </a:p>
         </p:txBody>
       </p:sp>
@@ -1383,7 +1383,7 @@
               <a:rPr lang="en-US"/>
               <a:t>Fifth level</a:t>
             </a:r>
-            <a:endParaRPr lang="ru-RU"/>
+            <a:endParaRPr lang="en-US"/>
           </a:p>
         </p:txBody>
       </p:sp>
@@ -1409,10 +1409,10 @@
           <a:lstStyle/>
           <a:p>
             <a:fld id="{961A2009-0CEE-41C1-939A-B9C723B78133}" type="datetimeFigureOut">
-              <a:rPr lang="ru-RU" smtClean="0"/>
+              <a:rPr lang="en-US" smtClean="0"/>
               <a:t>05.03.2026</a:t>
             </a:fld>
-            <a:endParaRPr lang="ru-RU"/>
+            <a:endParaRPr lang="en-US"/>
           </a:p>
         </p:txBody>
       </p:sp>
@@ -1437,7 +1437,7 @@
           <a:bodyPr/>
           <a:lstStyle/>
           <a:p>
-            <a:endParaRPr lang="ru-RU"/>
+            <a:endParaRPr lang="en-US"/>
           </a:p>
         </p:txBody>
       </p:sp>
@@ -1463,10 +1463,10 @@
           <a:lstStyle/>
           <a:p>
             <a:fld id="{20CA96BB-6BF3-4E52-BE21-7A7A15C0727C}" type="slidenum">
-              <a:rPr lang="ru-RU" smtClean="0"/>
+              <a:rPr lang="en-US" smtClean="0"/>
               <a:t>‹#›</a:t>
             </a:fld>
-            <a:endParaRPr lang="ru-RU"/>
+            <a:endParaRPr lang="en-US"/>
           </a:p>
         </p:txBody>
       </p:sp>
@@ -1530,7 +1530,7 @@
               <a:rPr lang="en-US"/>
               <a:t>Click to edit Master title style</a:t>
             </a:r>
-            <a:endParaRPr lang="ru-RU"/>
+            <a:endParaRPr lang="en-US"/>
           </a:p>
         </p:txBody>
       </p:sp>
@@ -1664,7 +1664,7 @@
               <a:rPr lang="en-US"/>
               <a:t>Fifth level</a:t>
             </a:r>
-            <a:endParaRPr lang="ru-RU"/>
+            <a:endParaRPr lang="en-US"/>
           </a:p>
         </p:txBody>
       </p:sp>
@@ -1798,7 +1798,7 @@
               <a:rPr lang="en-US"/>
               <a:t>Fifth level</a:t>
             </a:r>
-            <a:endParaRPr lang="ru-RU"/>
+            <a:endParaRPr lang="en-US"/>
           </a:p>
         </p:txBody>
       </p:sp>
@@ -1824,10 +1824,10 @@
           <a:lstStyle/>
           <a:p>
             <a:fld id="{961A2009-0CEE-41C1-939A-B9C723B78133}" type="datetimeFigureOut">
-              <a:rPr lang="ru-RU" smtClean="0"/>
+              <a:rPr lang="en-US" smtClean="0"/>
               <a:t>05.03.2026</a:t>
             </a:fld>
-            <a:endParaRPr lang="ru-RU"/>
+            <a:endParaRPr lang="en-US"/>
           </a:p>
         </p:txBody>
       </p:sp>
@@ -1852,7 +1852,7 @@
           <a:bodyPr/>
           <a:lstStyle/>
           <a:p>
-            <a:endParaRPr lang="ru-RU"/>
+            <a:endParaRPr lang="en-US"/>
           </a:p>
         </p:txBody>
       </p:sp>
@@ -1878,10 +1878,10 @@
           <a:lstStyle/>
           <a:p>
             <a:fld id="{20CA96BB-6BF3-4E52-BE21-7A7A15C0727C}" type="slidenum">
-              <a:rPr lang="ru-RU" smtClean="0"/>
+              <a:rPr lang="en-US" smtClean="0"/>
               <a:t>‹#›</a:t>
             </a:fld>
-            <a:endParaRPr lang="ru-RU"/>
+            <a:endParaRPr lang="en-US"/>
           </a:p>
         </p:txBody>
       </p:sp>
@@ -1940,7 +1940,7 @@
               <a:rPr lang="en-US"/>
               <a:t>Click to edit Master title style</a:t>
             </a:r>
-            <a:endParaRPr lang="ru-RU"/>
+            <a:endParaRPr lang="en-US"/>
           </a:p>
         </p:txBody>
       </p:sp>
@@ -1966,10 +1966,10 @@
           <a:lstStyle/>
           <a:p>
             <a:fld id="{961A2009-0CEE-41C1-939A-B9C723B78133}" type="datetimeFigureOut">
-              <a:rPr lang="ru-RU" smtClean="0"/>
+              <a:rPr lang="en-US" smtClean="0"/>
               <a:t>05.03.2026</a:t>
             </a:fld>
-            <a:endParaRPr lang="ru-RU"/>
+            <a:endParaRPr lang="en-US"/>
           </a:p>
         </p:txBody>
       </p:sp>
@@ -1994,7 +1994,7 @@
           <a:bodyPr/>
           <a:lstStyle/>
           <a:p>
-            <a:endParaRPr lang="ru-RU"/>
+            <a:endParaRPr lang="en-US"/>
           </a:p>
         </p:txBody>
       </p:sp>
@@ -2020,10 +2020,10 @@
           <a:lstStyle/>
           <a:p>
             <a:fld id="{20CA96BB-6BF3-4E52-BE21-7A7A15C0727C}" type="slidenum">
-              <a:rPr lang="ru-RU" smtClean="0"/>
+              <a:rPr lang="en-US" smtClean="0"/>
               <a:t>‹#›</a:t>
             </a:fld>
-            <a:endParaRPr lang="ru-RU"/>
+            <a:endParaRPr lang="en-US"/>
           </a:p>
         </p:txBody>
       </p:sp>
@@ -2079,10 +2079,10 @@
           <a:lstStyle/>
           <a:p>
             <a:fld id="{961A2009-0CEE-41C1-939A-B9C723B78133}" type="datetimeFigureOut">
-              <a:rPr lang="ru-RU" smtClean="0"/>
+              <a:rPr lang="en-US" smtClean="0"/>
               <a:t>05.03.2026</a:t>
             </a:fld>
-            <a:endParaRPr lang="ru-RU"/>
+            <a:endParaRPr lang="en-US"/>
           </a:p>
         </p:txBody>
       </p:sp>
@@ -2107,7 +2107,7 @@
           <a:bodyPr/>
           <a:lstStyle/>
           <a:p>
-            <a:endParaRPr lang="ru-RU"/>
+            <a:endParaRPr lang="en-US"/>
           </a:p>
         </p:txBody>
       </p:sp>
@@ -2133,10 +2133,10 @@
           <a:lstStyle/>
           <a:p>
             <a:fld id="{20CA96BB-6BF3-4E52-BE21-7A7A15C0727C}" type="slidenum">
-              <a:rPr lang="ru-RU" smtClean="0"/>
+              <a:rPr lang="en-US" smtClean="0"/>
               <a:t>‹#›</a:t>
             </a:fld>
-            <a:endParaRPr lang="ru-RU"/>
+            <a:endParaRPr lang="en-US"/>
           </a:p>
         </p:txBody>
       </p:sp>
@@ -2204,7 +2204,7 @@
               <a:rPr lang="en-US"/>
               <a:t>Click to edit Master title style</a:t>
             </a:r>
-            <a:endParaRPr lang="ru-RU"/>
+            <a:endParaRPr lang="en-US"/>
           </a:p>
         </p:txBody>
       </p:sp>
@@ -2295,7 +2295,7 @@
               <a:rPr lang="en-US"/>
               <a:t>Fifth level</a:t>
             </a:r>
-            <a:endParaRPr lang="ru-RU"/>
+            <a:endParaRPr lang="en-US"/>
           </a:p>
         </p:txBody>
       </p:sp>
@@ -2392,10 +2392,10 @@
           <a:lstStyle/>
           <a:p>
             <a:fld id="{961A2009-0CEE-41C1-939A-B9C723B78133}" type="datetimeFigureOut">
-              <a:rPr lang="ru-RU" smtClean="0"/>
+              <a:rPr lang="en-US" smtClean="0"/>
               <a:t>05.03.2026</a:t>
             </a:fld>
-            <a:endParaRPr lang="ru-RU"/>
+            <a:endParaRPr lang="en-US"/>
           </a:p>
         </p:txBody>
       </p:sp>
@@ -2420,7 +2420,7 @@
           <a:bodyPr/>
           <a:lstStyle/>
           <a:p>
-            <a:endParaRPr lang="ru-RU"/>
+            <a:endParaRPr lang="en-US"/>
           </a:p>
         </p:txBody>
       </p:sp>
@@ -2446,10 +2446,10 @@
           <a:lstStyle/>
           <a:p>
             <a:fld id="{20CA96BB-6BF3-4E52-BE21-7A7A15C0727C}" type="slidenum">
-              <a:rPr lang="ru-RU" smtClean="0"/>
+              <a:rPr lang="en-US" smtClean="0"/>
               <a:t>‹#›</a:t>
             </a:fld>
-            <a:endParaRPr lang="ru-RU"/>
+            <a:endParaRPr lang="en-US"/>
           </a:p>
         </p:txBody>
       </p:sp>
@@ -2517,7 +2517,7 @@
               <a:rPr lang="en-US"/>
               <a:t>Click to edit Master title style</a:t>
             </a:r>
-            <a:endParaRPr lang="ru-RU"/>
+            <a:endParaRPr lang="en-US"/>
           </a:p>
         </p:txBody>
       </p:sp>
@@ -2584,7 +2584,7 @@
             </a:lvl9pPr>
           </a:lstStyle>
           <a:p>
-            <a:endParaRPr lang="ru-RU"/>
+            <a:endParaRPr lang="en-US"/>
           </a:p>
         </p:txBody>
       </p:sp>
@@ -2681,10 +2681,10 @@
           <a:lstStyle/>
           <a:p>
             <a:fld id="{961A2009-0CEE-41C1-939A-B9C723B78133}" type="datetimeFigureOut">
-              <a:rPr lang="ru-RU" smtClean="0"/>
+              <a:rPr lang="en-US" smtClean="0"/>
               <a:t>05.03.2026</a:t>
             </a:fld>
-            <a:endParaRPr lang="ru-RU"/>
+            <a:endParaRPr lang="en-US"/>
           </a:p>
         </p:txBody>
       </p:sp>
@@ -2709,7 +2709,7 @@
           <a:bodyPr/>
           <a:lstStyle/>
           <a:p>
-            <a:endParaRPr lang="ru-RU"/>
+            <a:endParaRPr lang="en-US"/>
           </a:p>
         </p:txBody>
       </p:sp>
@@ -2735,10 +2735,10 @@
           <a:lstStyle/>
           <a:p>
             <a:fld id="{20CA96BB-6BF3-4E52-BE21-7A7A15C0727C}" type="slidenum">
-              <a:rPr lang="ru-RU" smtClean="0"/>
+              <a:rPr lang="en-US" smtClean="0"/>
               <a:t>‹#›</a:t>
             </a:fld>
-            <a:endParaRPr lang="ru-RU"/>
+            <a:endParaRPr lang="en-US"/>
           </a:p>
         </p:txBody>
       </p:sp>
@@ -2812,7 +2812,7 @@
               <a:rPr lang="en-US"/>
               <a:t>Click to edit Master title style</a:t>
             </a:r>
-            <a:endParaRPr lang="ru-RU"/>
+            <a:endParaRPr lang="en-US"/>
           </a:p>
         </p:txBody>
       </p:sp>
@@ -2880,7 +2880,7 @@
               <a:rPr lang="en-US"/>
               <a:t>Fifth level</a:t>
             </a:r>
-            <a:endParaRPr lang="ru-RU"/>
+            <a:endParaRPr lang="en-US"/>
           </a:p>
         </p:txBody>
       </p:sp>
@@ -2924,10 +2924,10 @@
           </a:lstStyle>
           <a:p>
             <a:fld id="{961A2009-0CEE-41C1-939A-B9C723B78133}" type="datetimeFigureOut">
-              <a:rPr lang="ru-RU" smtClean="0"/>
+              <a:rPr lang="en-US" smtClean="0"/>
               <a:t>05.03.2026</a:t>
             </a:fld>
-            <a:endParaRPr lang="ru-RU"/>
+            <a:endParaRPr lang="en-US"/>
           </a:p>
         </p:txBody>
       </p:sp>
@@ -2970,7 +2970,7 @@
             </a:lvl1pPr>
           </a:lstStyle>
           <a:p>
-            <a:endParaRPr lang="ru-RU"/>
+            <a:endParaRPr lang="en-US"/>
           </a:p>
         </p:txBody>
       </p:sp>
@@ -3014,10 +3014,10 @@
           </a:lstStyle>
           <a:p>
             <a:fld id="{20CA96BB-6BF3-4E52-BE21-7A7A15C0727C}" type="slidenum">
-              <a:rPr lang="ru-RU" smtClean="0"/>
+              <a:rPr lang="en-US" smtClean="0"/>
               <a:t>‹#›</a:t>
             </a:fld>
-            <a:endParaRPr lang="ru-RU"/>
+            <a:endParaRPr lang="en-US"/>
           </a:p>
         </p:txBody>
       </p:sp>
@@ -3228,7 +3228,7 @@
     </p:bodyStyle>
     <p:otherStyle>
       <a:defPPr>
-        <a:defRPr lang="ru-RU"/>
+        <a:defRPr lang="en-US"/>
       </a:defPPr>
       <a:lvl1pPr marL="0" algn="l" defTabSz="914400" rtl="0" eaLnBrk="1" latinLnBrk="0" hangingPunct="1">
         <a:defRPr sz="1800" kern="1200">

</xml_diff>